<commit_message>
Long agent sessions at 256 and 512 agents; tools renamed and documented
reports/agentic-4x-rtxpro6000-qwen3-235b-a22b/long-sessions/: LifeboatCache with 25-round
sessions (512-token cap, 40,192 context) at 256 and 512 agents, and 64 vs 256 GB of DRAM.
agentic/: intel_sweep.py is now agentic_sweep.py (outputs sweep_*.csv); serve.sh gains
LMCACHE_ODIRECT and KV_LOAD_FAILURE_POLICY. Updated deck and READMEs.

Co-Authored-By: Claude Opus 5.5 <noreply@anthropic.com>
</commit_message>
<xml_diff>
--- a/reports/agentic-4x-rtxpro6000-qwen3-235b-a22b/LifeboatCache_vLLM_Agentic_4xRTXPRO6000.pptx
+++ b/reports/agentic-4x-rtxpro6000-qwen3-235b-a22b/LifeboatCache_vLLM_Agentic_4xRTXPRO6000.pptx
@@ -18,9 +18,12 @@
     <p:sldId id="266" r:id="rId12"/>
     <p:sldId id="267" r:id="rId13"/>
     <p:sldId id="268" r:id="rId14"/>
+    <p:sldId id="269" r:id="rId15"/>
+    <p:sldId id="270" r:id="rId16"/>
+    <p:sldId id="271" r:id="rId17"/>
   </p:sldIdLst>
   <p:notesMasterIdLst>
-    <p:notesMasterId r:id="rId15"/>
+    <p:notesMasterId r:id="rId18"/>
   </p:notesMasterIdLst>
   <p:sldSz cx="12192000" cy="6858000"/>
   <p:notesSz cx="6858000" cy="12192000"/>
@@ -278,6 +281,1216 @@
         </c:ser>
         <c:dLbls>
           <c:numFmt formatCode="0.0" sourceLinked="0"/>
+          <c:txPr>
+            <a:bodyPr/>
+            <a:lstStyle/>
+            <a:p>
+              <a:pPr>
+                <a:defRPr b="0" i="0" strike="noStrike" sz="1200" u="none">
+                  <a:solidFill>
+                    <a:srgbClr val="1B2430"/>
+                  </a:solidFill>
+                  <a:latin typeface="+mn-lt"/>
+                </a:defRPr>
+              </a:pPr>
+            </a:p>
+          </c:txPr>
+          <c:showLegendKey val="0"/>
+          <c:showVal val="1"/>
+          <c:showCatName val="0"/>
+          <c:showSerName val="0"/>
+          <c:showPercent val="0"/>
+          <c:showBubbleSize val="0"/>
+          <c:showLeaderLines val="0"/>
+        </c:dLbls>
+        <c:gapWidth val="60"/>
+        <c:overlap val="0"/>
+        <c:axId val="2094734554"/>
+        <c:axId val="2094734552"/>
+        <c:axId val="2094734556"/>
+      </c:barChart>
+      <c:catAx>
+        <c:axId val="2094734554"/>
+        <c:scaling>
+          <c:orientation val="minMax"/>
+        </c:scaling>
+        <c:delete val="0"/>
+        <c:axPos val="b"/>
+        <c:numFmt formatCode="General" sourceLinked="1"/>
+        <c:majorTickMark val="out"/>
+        <c:minorTickMark val="none"/>
+        <c:tickLblPos val="low"/>
+        <c:spPr>
+          <a:ln w="12700" cap="flat">
+            <a:solidFill>
+              <a:srgbClr val="888888"/>
+            </a:solidFill>
+            <a:prstDash val="solid"/>
+            <a:round/>
+          </a:ln>
+        </c:spPr>
+        <c:txPr>
+          <a:bodyPr/>
+          <a:lstStyle/>
+          <a:p>
+            <a:pPr>
+              <a:defRPr sz="1200" b="0" i="0" u="none" strike="noStrike">
+                <a:solidFill>
+                  <a:srgbClr val="1B2430"/>
+                </a:solidFill>
+                <a:latin typeface="+mn-lt"/>
+              </a:defRPr>
+            </a:pPr>
+            <a:endParaRPr lang="en-US"/>
+          </a:p>
+        </c:txPr>
+        <c:crossAx val="2094734552"/>
+        <c:crosses val="autoZero"/>
+        <c:auto val="1"/>
+        <c:lblAlgn val="ctr"/>
+        <c:noMultiLvlLbl val="1"/>
+      </c:catAx>
+      <c:valAx>
+        <c:axId val="2094734552"/>
+        <c:scaling>
+          <c:orientation val="minMax"/>
+          <c:min val="0"/>
+        </c:scaling>
+        <c:delete val="0"/>
+        <c:axPos val="l"/>
+        <c:majorGridlines>
+          <c:spPr>
+            <a:ln w="9525" cap="flat">
+              <a:solidFill>
+                <a:srgbClr val="D9E0E7"/>
+              </a:solidFill>
+              <a:prstDash val="solid"/>
+              <a:round/>
+            </a:ln>
+          </c:spPr>
+        </c:majorGridlines>
+        <c:numFmt formatCode="General" sourceLinked="0"/>
+        <c:majorTickMark val="out"/>
+        <c:minorTickMark val="none"/>
+        <c:tickLblPos val="nextTo"/>
+        <c:spPr>
+          <a:ln w="12700" cap="flat">
+            <a:solidFill>
+              <a:srgbClr val="888888"/>
+            </a:solidFill>
+            <a:prstDash val="solid"/>
+            <a:round/>
+          </a:ln>
+        </c:spPr>
+        <c:txPr>
+          <a:bodyPr/>
+          <a:lstStyle/>
+          <a:p>
+            <a:pPr>
+              <a:defRPr sz="1100" b="0" i="0" u="none" strike="noStrike">
+                <a:solidFill>
+                  <a:srgbClr val="5B6C8F"/>
+                </a:solidFill>
+                <a:latin typeface="+mn-lt"/>
+              </a:defRPr>
+            </a:pPr>
+            <a:endParaRPr lang="en-US"/>
+          </a:p>
+        </c:txPr>
+        <c:crossAx val="2094734554"/>
+        <c:crosses val="autoZero"/>
+        <c:crossBetween val="between"/>
+      </c:valAx>
+      <c:spPr>
+        <a:noFill/>
+        <a:ln>
+          <a:noFill/>
+        </a:ln>
+        <a:effectLst/>
+      </c:spPr>
+    </c:plotArea>
+    <c:plotVisOnly val="1"/>
+    <c:dispBlanksAs val="span"/>
+  </c:chart>
+  <c:spPr>
+    <a:noFill/>
+    <a:ln>
+      <a:noFill/>
+    </a:ln>
+    <a:effectLst/>
+  </c:spPr>
+  <c:externalData r:id="rId1">
+    <c:autoUpdate val="0"/>
+  </c:externalData>
+</c:chartSpace>
+</file>
+
+<file path=ppt/charts/chart10.xml><?xml version="1.0" encoding="utf-8"?>
+<c:chartSpace xmlns:c="http://schemas.openxmlformats.org/drawingml/2006/chart" xmlns:a="http://schemas.openxmlformats.org/drawingml/2006/main" xmlns:r="http://schemas.openxmlformats.org/officeDocument/2006/relationships">
+  <c:date1904 val="0"/>
+  <c:roundedCorners val="1"/>
+  <c:chart>
+    <c:title>
+      <c:tx>
+        <c:rich>
+          <a:bodyPr/>
+          <a:lstStyle/>
+          <a:p>
+            <a:pPr>
+              <a:defRPr sz="1400" b="0" i="0" u="none" strike="noStrike">
+                <a:solidFill>
+                  <a:srgbClr val="1B2430"/>
+                </a:solidFill>
+                <a:latin typeface="+mn-lt"/>
+              </a:defRPr>
+            </a:pPr>
+            <a:r>
+              <a:rPr sz="1400" b="0" i="0" u="none" strike="noStrike">
+                <a:solidFill>
+                  <a:srgbClr val="1B2430"/>
+                </a:solidFill>
+                <a:latin typeface="+mn-lt"/>
+              </a:rPr>
+              <a:t>Generation throughput (tok/s)</a:t>
+            </a:r>
+          </a:p>
+        </c:rich>
+      </c:tx>
+      <c:layout/>
+      <c:overlay val="0"/>
+    </c:title>
+    <c:autoTitleDeleted val="0"/>
+    <c:plotArea>
+      <c:layout/>
+      <c:lineChart>
+        <c:varyColors val="0"/>
+        <c:ser>
+          <c:idx val="0"/>
+          <c:order val="0"/>
+          <c:tx>
+            <c:strRef>
+              <c:f>Sheet1!$B$1</c:f>
+              <c:strCache>
+                <c:ptCount val="1"/>
+                <c:pt idx="0">
+                  <c:v>vLLM + LMCache (DRAM + NVMe)</c:v>
+                </c:pt>
+              </c:strCache>
+            </c:strRef>
+          </c:tx>
+          <c:spPr>
+            <a:solidFill>
+              <a:srgbClr val="5B6C8F"/>
+            </a:solidFill>
+            <a:ln w="38100" cap="flat">
+              <a:solidFill>
+                <a:srgbClr val="5B6C8F"/>
+              </a:solidFill>
+              <a:prstDash val="solid"/>
+              <a:round/>
+            </a:ln>
+            <a:effectLst/>
+          </c:spPr>
+          <c:invertIfNegative val="0"/>
+          <c:dLbls>
+            <c:numFmt formatCode="#,##0" sourceLinked="0"/>
+            <c:txPr>
+              <a:bodyPr/>
+              <a:lstStyle/>
+              <a:p>
+                <a:pPr>
+                  <a:defRPr b="0" i="0" strike="noStrike" sz="1200" u="none">
+                    <a:solidFill>
+                      <a:srgbClr val="1B2430"/>
+                    </a:solidFill>
+                    <a:latin typeface="+mn-lt"/>
+                  </a:defRPr>
+                </a:pPr>
+              </a:p>
+            </c:txPr>
+            <c:showLegendKey val="0"/>
+            <c:showVal val="0"/>
+            <c:showCatName val="0"/>
+            <c:showSerName val="0"/>
+            <c:showPercent val="0"/>
+            <c:showBubbleSize val="0"/>
+            <c:showLeaderLines val="0"/>
+          </c:dLbls>
+          <c:marker>
+            <c:symbol val="none"/>
+            <c:size val="6"/>
+            <c:spPr>
+              <a:solidFill>
+                <a:srgbClr val="5B6C8F"/>
+              </a:solidFill>
+              <a:ln w="9525" cap="flat">
+                <a:solidFill>
+                  <a:srgbClr val="5B6C8F"/>
+                </a:solidFill>
+                <a:prstDash val="solid"/>
+                <a:round/>
+              </a:ln>
+              <a:effectLst/>
+            </c:spPr>
+          </c:marker>
+          <c:cat>
+            <c:multiLvlStrRef>
+              <c:f>Sheet1!$A$2:$A$20</c:f>
+              <c:multiLvlStrCache>
+                <c:ptCount val="19"/>
+                <c:lvl>
+                  <c:pt idx="0">
+                    <c:v>0</c:v>
+                  </c:pt>
+                  <c:pt idx="1">
+                    <c:v>5</c:v>
+                  </c:pt>
+                  <c:pt idx="2">
+                    <c:v>10</c:v>
+                  </c:pt>
+                  <c:pt idx="3">
+                    <c:v>15</c:v>
+                  </c:pt>
+                  <c:pt idx="4">
+                    <c:v>20</c:v>
+                  </c:pt>
+                  <c:pt idx="5">
+                    <c:v>25</c:v>
+                  </c:pt>
+                  <c:pt idx="6">
+                    <c:v>30</c:v>
+                  </c:pt>
+                  <c:pt idx="7">
+                    <c:v>35</c:v>
+                  </c:pt>
+                  <c:pt idx="8">
+                    <c:v>40</c:v>
+                  </c:pt>
+                  <c:pt idx="9">
+                    <c:v>45</c:v>
+                  </c:pt>
+                  <c:pt idx="10">
+                    <c:v>50</c:v>
+                  </c:pt>
+                  <c:pt idx="11">
+                    <c:v>55</c:v>
+                  </c:pt>
+                  <c:pt idx="12">
+                    <c:v>60</c:v>
+                  </c:pt>
+                  <c:pt idx="13">
+                    <c:v>65</c:v>
+                  </c:pt>
+                  <c:pt idx="14">
+                    <c:v>70</c:v>
+                  </c:pt>
+                  <c:pt idx="15">
+                    <c:v>75</c:v>
+                  </c:pt>
+                  <c:pt idx="16">
+                    <c:v>80</c:v>
+                  </c:pt>
+                  <c:pt idx="17">
+                    <c:v>85</c:v>
+                  </c:pt>
+                  <c:pt idx="18">
+                    <c:v>90</c:v>
+                  </c:pt>
+                </c:lvl>
+              </c:multiLvlStrCache>
+            </c:multiLvlStrRef>
+          </c:cat>
+          <c:val>
+            <c:numRef>
+              <c:f>Sheet1!$B$2:$B$20</c:f>
+              <c:numCache>
+                <c:formatCode>General</c:formatCode>
+                <c:ptCount val="19"/>
+                <c:pt idx="0">
+                  <c:v>119</c:v>
+                </c:pt>
+                <c:pt idx="1">
+                  <c:v>258</c:v>
+                </c:pt>
+                <c:pt idx="2">
+                  <c:v>233</c:v>
+                </c:pt>
+                <c:pt idx="3">
+                  <c:v>240</c:v>
+                </c:pt>
+                <c:pt idx="4">
+                  <c:v>259</c:v>
+                </c:pt>
+                <c:pt idx="5">
+                  <c:v>259</c:v>
+                </c:pt>
+                <c:pt idx="6">
+                  <c:v>228</c:v>
+                </c:pt>
+                <c:pt idx="7">
+                  <c:v>171</c:v>
+                </c:pt>
+                <c:pt idx="8">
+                  <c:v>149</c:v>
+                </c:pt>
+                <c:pt idx="9">
+                  <c:v>137</c:v>
+                </c:pt>
+                <c:pt idx="10">
+                  <c:v>113</c:v>
+                </c:pt>
+                <c:pt idx="11">
+                  <c:v>110</c:v>
+                </c:pt>
+                <c:pt idx="12">
+                  <c:v>89</c:v>
+                </c:pt>
+                <c:pt idx="13">
+                  <c:v>61</c:v>
+                </c:pt>
+                <c:pt idx="14">
+                  <c:v>45</c:v>
+                </c:pt>
+                <c:pt idx="15">
+                  <c:v>54</c:v>
+                </c:pt>
+                <c:pt idx="16">
+                  <c:v>54</c:v>
+                </c:pt>
+                <c:pt idx="17">
+                  <c:v>45</c:v>
+                </c:pt>
+                <c:pt idx="18">
+                  <c:v>52</c:v>
+                </c:pt>
+              </c:numCache>
+            </c:numRef>
+          </c:val>
+          <c:smooth val="0"/>
+        </c:ser>
+        <c:ser>
+          <c:idx val="1"/>
+          <c:order val="1"/>
+          <c:tx>
+            <c:strRef>
+              <c:f>Sheet1!$C$1</c:f>
+              <c:strCache>
+                <c:ptCount val="1"/>
+                <c:pt idx="0">
+                  <c:v>vLLM + LifeboatCache</c:v>
+                </c:pt>
+              </c:strCache>
+            </c:strRef>
+          </c:tx>
+          <c:spPr>
+            <a:solidFill>
+              <a:srgbClr val="0E9F8E"/>
+            </a:solidFill>
+            <a:ln w="38100" cap="flat">
+              <a:solidFill>
+                <a:srgbClr val="0E9F8E"/>
+              </a:solidFill>
+              <a:prstDash val="solid"/>
+              <a:round/>
+            </a:ln>
+            <a:effectLst/>
+          </c:spPr>
+          <c:invertIfNegative val="0"/>
+          <c:dLbls>
+            <c:numFmt formatCode="#,##0" sourceLinked="0"/>
+            <c:txPr>
+              <a:bodyPr/>
+              <a:lstStyle/>
+              <a:p>
+                <a:pPr>
+                  <a:defRPr b="0" i="0" strike="noStrike" sz="1200" u="none">
+                    <a:solidFill>
+                      <a:srgbClr val="1B2430"/>
+                    </a:solidFill>
+                    <a:latin typeface="+mn-lt"/>
+                  </a:defRPr>
+                </a:pPr>
+              </a:p>
+            </c:txPr>
+            <c:showLegendKey val="0"/>
+            <c:showVal val="0"/>
+            <c:showCatName val="0"/>
+            <c:showSerName val="0"/>
+            <c:showPercent val="0"/>
+            <c:showBubbleSize val="0"/>
+            <c:showLeaderLines val="0"/>
+          </c:dLbls>
+          <c:marker>
+            <c:symbol val="none"/>
+            <c:size val="6"/>
+            <c:spPr>
+              <a:solidFill>
+                <a:srgbClr val="0E9F8E"/>
+              </a:solidFill>
+              <a:ln w="9525" cap="flat">
+                <a:solidFill>
+                  <a:srgbClr val="0E9F8E"/>
+                </a:solidFill>
+                <a:prstDash val="solid"/>
+                <a:round/>
+              </a:ln>
+              <a:effectLst/>
+            </c:spPr>
+          </c:marker>
+          <c:cat>
+            <c:multiLvlStrRef>
+              <c:f>Sheet1!$A$2:$A$20</c:f>
+              <c:multiLvlStrCache>
+                <c:ptCount val="19"/>
+                <c:lvl>
+                  <c:pt idx="0">
+                    <c:v>0</c:v>
+                  </c:pt>
+                  <c:pt idx="1">
+                    <c:v>5</c:v>
+                  </c:pt>
+                  <c:pt idx="2">
+                    <c:v>10</c:v>
+                  </c:pt>
+                  <c:pt idx="3">
+                    <c:v>15</c:v>
+                  </c:pt>
+                  <c:pt idx="4">
+                    <c:v>20</c:v>
+                  </c:pt>
+                  <c:pt idx="5">
+                    <c:v>25</c:v>
+                  </c:pt>
+                  <c:pt idx="6">
+                    <c:v>30</c:v>
+                  </c:pt>
+                  <c:pt idx="7">
+                    <c:v>35</c:v>
+                  </c:pt>
+                  <c:pt idx="8">
+                    <c:v>40</c:v>
+                  </c:pt>
+                  <c:pt idx="9">
+                    <c:v>45</c:v>
+                  </c:pt>
+                  <c:pt idx="10">
+                    <c:v>50</c:v>
+                  </c:pt>
+                  <c:pt idx="11">
+                    <c:v>55</c:v>
+                  </c:pt>
+                  <c:pt idx="12">
+                    <c:v>60</c:v>
+                  </c:pt>
+                  <c:pt idx="13">
+                    <c:v>65</c:v>
+                  </c:pt>
+                  <c:pt idx="14">
+                    <c:v>70</c:v>
+                  </c:pt>
+                  <c:pt idx="15">
+                    <c:v>75</c:v>
+                  </c:pt>
+                  <c:pt idx="16">
+                    <c:v>80</c:v>
+                  </c:pt>
+                  <c:pt idx="17">
+                    <c:v>85</c:v>
+                  </c:pt>
+                  <c:pt idx="18">
+                    <c:v>90</c:v>
+                  </c:pt>
+                </c:lvl>
+              </c:multiLvlStrCache>
+            </c:multiLvlStrRef>
+          </c:cat>
+          <c:val>
+            <c:numRef>
+              <c:f>Sheet1!$C$2:$C$20</c:f>
+              <c:numCache>
+                <c:formatCode>General</c:formatCode>
+                <c:ptCount val="19"/>
+                <c:pt idx="0">
+                  <c:v>122</c:v>
+                </c:pt>
+                <c:pt idx="1">
+                  <c:v>258</c:v>
+                </c:pt>
+                <c:pt idx="2">
+                  <c:v>227</c:v>
+                </c:pt>
+                <c:pt idx="3">
+                  <c:v>231</c:v>
+                </c:pt>
+                <c:pt idx="4">
+                  <c:v>251</c:v>
+                </c:pt>
+                <c:pt idx="5">
+                  <c:v>273</c:v>
+                </c:pt>
+                <c:pt idx="6">
+                  <c:v>256</c:v>
+                </c:pt>
+                <c:pt idx="7">
+                  <c:v>232</c:v>
+                </c:pt>
+                <c:pt idx="8">
+                  <c:v>208</c:v>
+                </c:pt>
+                <c:pt idx="9">
+                  <c:v>221</c:v>
+                </c:pt>
+                <c:pt idx="10">
+                  <c:v>226</c:v>
+                </c:pt>
+                <c:pt idx="11">
+                  <c:v>188</c:v>
+                </c:pt>
+                <c:pt idx="12">
+                  <c:v>217</c:v>
+                </c:pt>
+                <c:pt idx="13">
+                  <c:v>234</c:v>
+                </c:pt>
+                <c:pt idx="14">
+                  <c:v>198</c:v>
+                </c:pt>
+                <c:pt idx="15">
+                  <c:v>200</c:v>
+                </c:pt>
+                <c:pt idx="16">
+                  <c:v/>
+                </c:pt>
+                <c:pt idx="17">
+                  <c:v/>
+                </c:pt>
+                <c:pt idx="18">
+                  <c:v/>
+                </c:pt>
+              </c:numCache>
+            </c:numRef>
+          </c:val>
+          <c:smooth val="0"/>
+        </c:ser>
+        <c:dLbls>
+          <c:numFmt formatCode="#,##0" sourceLinked="0"/>
+          <c:txPr>
+            <a:bodyPr/>
+            <a:lstStyle/>
+            <a:p>
+              <a:pPr>
+                <a:defRPr b="0" i="0" strike="noStrike" sz="1200" u="none">
+                  <a:solidFill>
+                    <a:srgbClr val="1B2430"/>
+                  </a:solidFill>
+                  <a:latin typeface="+mn-lt"/>
+                </a:defRPr>
+              </a:pPr>
+            </a:p>
+          </c:txPr>
+          <c:showLegendKey val="0"/>
+          <c:showVal val="0"/>
+          <c:showCatName val="0"/>
+          <c:showSerName val="0"/>
+          <c:showPercent val="0"/>
+          <c:showBubbleSize val="0"/>
+          <c:showLeaderLines val="0"/>
+        </c:dLbls>
+        <c:marker val="1"/>
+        <c:axId val="2094734554"/>
+        <c:axId val="2094734552"/>
+        <c:axId val="2094734556"/>
+      </c:lineChart>
+      <c:catAx>
+        <c:axId val="2094734554"/>
+        <c:scaling>
+          <c:orientation val="minMax"/>
+        </c:scaling>
+        <c:delete val="0"/>
+        <c:axPos val="b"/>
+        <c:title>
+          <c:tx>
+            <c:rich>
+              <a:bodyPr/>
+              <a:lstStyle/>
+              <a:p>
+                <a:pPr>
+                  <a:defRPr b="0" i="0" u="none" strike="noStrike">
+                    <a:solidFill>
+                      <a:srgbClr val="000000"/>
+                    </a:solidFill>
+                    <a:latin typeface="Arial"/>
+                  </a:defRPr>
+                </a:pPr>
+                <a:r>
+                  <a:rPr b="0" i="0" u="none" strike="noStrike">
+                    <a:solidFill>
+                      <a:srgbClr val="000000"/>
+                    </a:solidFill>
+                    <a:latin typeface="Arial"/>
+                  </a:rPr>
+                  <a:t>minutes</a:t>
+                </a:r>
+              </a:p>
+            </c:rich>
+          </c:tx>
+          <c:layout/>
+          <c:overlay val="0"/>
+        </c:title>
+        <c:numFmt formatCode="General" sourceLinked="1"/>
+        <c:majorTickMark val="out"/>
+        <c:minorTickMark val="none"/>
+        <c:tickLblPos val="low"/>
+        <c:spPr>
+          <a:ln w="12700" cap="flat">
+            <a:solidFill>
+              <a:srgbClr val="888888"/>
+            </a:solidFill>
+            <a:prstDash val="solid"/>
+            <a:round/>
+          </a:ln>
+        </c:spPr>
+        <c:txPr>
+          <a:bodyPr/>
+          <a:lstStyle/>
+          <a:p>
+            <a:pPr>
+              <a:defRPr sz="1200" b="0" i="0" u="none" strike="noStrike">
+                <a:solidFill>
+                  <a:srgbClr val="1B2430"/>
+                </a:solidFill>
+                <a:latin typeface="+mn-lt"/>
+              </a:defRPr>
+            </a:pPr>
+            <a:endParaRPr lang="en-US"/>
+          </a:p>
+        </c:txPr>
+        <c:crossAx val="2094734552"/>
+        <c:crosses val="autoZero"/>
+        <c:auto val="1"/>
+        <c:lblAlgn val="ctr"/>
+        <c:noMultiLvlLbl val="1"/>
+      </c:catAx>
+      <c:valAx>
+        <c:axId val="2094734552"/>
+        <c:scaling>
+          <c:orientation val="minMax"/>
+          <c:min val="0"/>
+        </c:scaling>
+        <c:delete val="0"/>
+        <c:axPos val="l"/>
+        <c:majorGridlines>
+          <c:spPr>
+            <a:ln w="9525" cap="flat">
+              <a:solidFill>
+                <a:srgbClr val="D9E0E7"/>
+              </a:solidFill>
+              <a:prstDash val="solid"/>
+              <a:round/>
+            </a:ln>
+          </c:spPr>
+        </c:majorGridlines>
+        <c:numFmt formatCode="General" sourceLinked="0"/>
+        <c:majorTickMark val="out"/>
+        <c:minorTickMark val="none"/>
+        <c:tickLblPos val="nextTo"/>
+        <c:spPr>
+          <a:ln w="12700" cap="flat">
+            <a:solidFill>
+              <a:srgbClr val="888888"/>
+            </a:solidFill>
+            <a:prstDash val="solid"/>
+            <a:round/>
+          </a:ln>
+        </c:spPr>
+        <c:txPr>
+          <a:bodyPr/>
+          <a:lstStyle/>
+          <a:p>
+            <a:pPr>
+              <a:defRPr sz="1100" b="0" i="0" u="none" strike="noStrike">
+                <a:solidFill>
+                  <a:srgbClr val="5B6C8F"/>
+                </a:solidFill>
+                <a:latin typeface="+mn-lt"/>
+              </a:defRPr>
+            </a:pPr>
+            <a:endParaRPr lang="en-US"/>
+          </a:p>
+        </c:txPr>
+        <c:crossAx val="2094734554"/>
+        <c:crosses val="autoZero"/>
+        <c:crossBetween val="between"/>
+      </c:valAx>
+      <c:spPr>
+        <a:noFill/>
+        <a:ln>
+          <a:noFill/>
+        </a:ln>
+        <a:effectLst/>
+      </c:spPr>
+    </c:plotArea>
+    <c:legend>
+      <c:legendPos val="b"/>
+      <c:overlay val="0"/>
+      <c:txPr>
+        <a:bodyPr/>
+        <a:lstStyle/>
+        <a:p>
+          <a:pPr>
+            <a:defRPr sz="1100">
+              <a:latin typeface="+mn-lt"/>
+              <a:cs typeface="+mn-lt"/>
+            </a:defRPr>
+          </a:pPr>
+          <a:endParaRPr lang="en-US"/>
+        </a:p>
+      </c:txPr>
+    </c:legend>
+    <c:plotVisOnly val="1"/>
+    <c:dispBlanksAs val="span"/>
+  </c:chart>
+  <c:spPr>
+    <a:noFill/>
+    <a:ln>
+      <a:noFill/>
+    </a:ln>
+    <a:effectLst/>
+  </c:spPr>
+  <c:externalData r:id="rId1">
+    <c:autoUpdate val="0"/>
+  </c:externalData>
+</c:chartSpace>
+</file>
+
+<file path=ppt/charts/chart11.xml><?xml version="1.0" encoding="utf-8"?>
+<c:chartSpace xmlns:c="http://schemas.openxmlformats.org/drawingml/2006/chart" xmlns:a="http://schemas.openxmlformats.org/drawingml/2006/main" xmlns:r="http://schemas.openxmlformats.org/officeDocument/2006/relationships">
+  <c:date1904 val="0"/>
+  <c:roundedCorners val="1"/>
+  <c:chart>
+    <c:title>
+      <c:tx>
+        <c:rich>
+          <a:bodyPr/>
+          <a:lstStyle/>
+          <a:p>
+            <a:pPr>
+              <a:defRPr sz="1400" b="0" i="0" u="none" strike="noStrike">
+                <a:solidFill>
+                  <a:srgbClr val="1B2430"/>
+                </a:solidFill>
+                <a:latin typeface="+mn-lt"/>
+              </a:defRPr>
+            </a:pPr>
+            <a:r>
+              <a:rPr sz="1400" b="0" i="0" u="none" strike="noStrike">
+                <a:solidFill>
+                  <a:srgbClr val="1B2430"/>
+                </a:solidFill>
+                <a:latin typeface="+mn-lt"/>
+              </a:rPr>
+              <a:t>Output tokens/s, 256 agents</a:t>
+            </a:r>
+          </a:p>
+        </c:rich>
+      </c:tx>
+      <c:layout/>
+      <c:overlay val="0"/>
+    </c:title>
+    <c:autoTitleDeleted val="0"/>
+    <c:plotArea>
+      <c:layout/>
+      <c:barChart>
+        <c:barDir val="col"/>
+        <c:grouping val="clustered"/>
+        <c:varyColors val="0"/>
+        <c:ser>
+          <c:idx val="0"/>
+          <c:order val="0"/>
+          <c:tx>
+            <c:strRef>
+              <c:f>Sheet1!$B$1</c:f>
+              <c:strCache>
+                <c:ptCount val="1"/>
+                <c:pt idx="0">
+                  <c:v>Output tok/s</c:v>
+                </c:pt>
+              </c:strCache>
+            </c:strRef>
+          </c:tx>
+          <c:spPr>
+            <a:solidFill>
+              <a:srgbClr val="8AC6BE"/>
+            </a:solidFill>
+            <a:effectLst/>
+          </c:spPr>
+          <c:invertIfNegative val="0"/>
+          <c:dLbls>
+            <c:numFmt formatCode="#,##0" sourceLinked="0"/>
+            <c:txPr>
+              <a:bodyPr/>
+              <a:lstStyle/>
+              <a:p>
+                <a:pPr>
+                  <a:defRPr b="0" i="0" strike="noStrike" sz="1200" u="none">
+                    <a:solidFill>
+                      <a:srgbClr val="1B2430"/>
+                    </a:solidFill>
+                    <a:latin typeface="+mn-lt"/>
+                  </a:defRPr>
+                </a:pPr>
+              </a:p>
+            </c:txPr>
+            <c:showLegendKey val="0"/>
+            <c:showVal val="1"/>
+            <c:showCatName val="0"/>
+            <c:showSerName val="0"/>
+            <c:showPercent val="0"/>
+            <c:showBubbleSize val="0"/>
+            <c:showLeaderLines val="0"/>
+          </c:dLbls>
+          <c:dPt>
+            <c:idx val="0"/>
+            <c:invertIfNegative val="0"/>
+            <c:bubble3D val="0"/>
+            <c:spPr>
+              <a:solidFill>
+                <a:srgbClr val="8AC6BE"/>
+              </a:solidFill>
+              <a:effectLst/>
+            </c:spPr>
+          </c:dPt>
+          <c:dPt>
+            <c:idx val="1"/>
+            <c:invertIfNegative val="0"/>
+            <c:bubble3D val="0"/>
+            <c:spPr>
+              <a:solidFill>
+                <a:srgbClr val="0E9F8E"/>
+              </a:solidFill>
+              <a:effectLst/>
+            </c:spPr>
+          </c:dPt>
+          <c:cat>
+            <c:multiLvlStrRef>
+              <c:f>Sheet1!$A$2:$A$3</c:f>
+              <c:multiLvlStrCache>
+                <c:ptCount val="2"/>
+                <c:lvl>
+                  <c:pt idx="0">
+                    <c:v>64 GB DRAM</c:v>
+                  </c:pt>
+                  <c:pt idx="1">
+                    <c:v>256 GB DRAM</c:v>
+                  </c:pt>
+                </c:lvl>
+              </c:multiLvlStrCache>
+            </c:multiLvlStrRef>
+          </c:cat>
+          <c:val>
+            <c:numRef>
+              <c:f>Sheet1!$B$2:$B$3</c:f>
+              <c:numCache>
+                <c:formatCode>General</c:formatCode>
+                <c:ptCount val="2"/>
+                <c:pt idx="0">
+                  <c:v>199</c:v>
+                </c:pt>
+                <c:pt idx="1">
+                  <c:v>223</c:v>
+                </c:pt>
+              </c:numCache>
+            </c:numRef>
+          </c:val>
+        </c:ser>
+        <c:dLbls>
+          <c:numFmt formatCode="#,##0" sourceLinked="0"/>
+          <c:txPr>
+            <a:bodyPr/>
+            <a:lstStyle/>
+            <a:p>
+              <a:pPr>
+                <a:defRPr b="0" i="0" strike="noStrike" sz="1200" u="none">
+                  <a:solidFill>
+                    <a:srgbClr val="1B2430"/>
+                  </a:solidFill>
+                  <a:latin typeface="+mn-lt"/>
+                </a:defRPr>
+              </a:pPr>
+            </a:p>
+          </c:txPr>
+          <c:showLegendKey val="0"/>
+          <c:showVal val="1"/>
+          <c:showCatName val="0"/>
+          <c:showSerName val="0"/>
+          <c:showPercent val="0"/>
+          <c:showBubbleSize val="0"/>
+          <c:showLeaderLines val="0"/>
+        </c:dLbls>
+        <c:gapWidth val="60"/>
+        <c:overlap val="0"/>
+        <c:axId val="2094734554"/>
+        <c:axId val="2094734552"/>
+        <c:axId val="2094734556"/>
+      </c:barChart>
+      <c:catAx>
+        <c:axId val="2094734554"/>
+        <c:scaling>
+          <c:orientation val="minMax"/>
+        </c:scaling>
+        <c:delete val="0"/>
+        <c:axPos val="b"/>
+        <c:numFmt formatCode="General" sourceLinked="1"/>
+        <c:majorTickMark val="out"/>
+        <c:minorTickMark val="none"/>
+        <c:tickLblPos val="low"/>
+        <c:spPr>
+          <a:ln w="12700" cap="flat">
+            <a:solidFill>
+              <a:srgbClr val="888888"/>
+            </a:solidFill>
+            <a:prstDash val="solid"/>
+            <a:round/>
+          </a:ln>
+        </c:spPr>
+        <c:txPr>
+          <a:bodyPr/>
+          <a:lstStyle/>
+          <a:p>
+            <a:pPr>
+              <a:defRPr sz="1200" b="0" i="0" u="none" strike="noStrike">
+                <a:solidFill>
+                  <a:srgbClr val="1B2430"/>
+                </a:solidFill>
+                <a:latin typeface="+mn-lt"/>
+              </a:defRPr>
+            </a:pPr>
+            <a:endParaRPr lang="en-US"/>
+          </a:p>
+        </c:txPr>
+        <c:crossAx val="2094734552"/>
+        <c:crosses val="autoZero"/>
+        <c:auto val="1"/>
+        <c:lblAlgn val="ctr"/>
+        <c:noMultiLvlLbl val="1"/>
+      </c:catAx>
+      <c:valAx>
+        <c:axId val="2094734552"/>
+        <c:scaling>
+          <c:orientation val="minMax"/>
+          <c:min val="0"/>
+        </c:scaling>
+        <c:delete val="0"/>
+        <c:axPos val="l"/>
+        <c:majorGridlines>
+          <c:spPr>
+            <a:ln w="9525" cap="flat">
+              <a:solidFill>
+                <a:srgbClr val="D9E0E7"/>
+              </a:solidFill>
+              <a:prstDash val="solid"/>
+              <a:round/>
+            </a:ln>
+          </c:spPr>
+        </c:majorGridlines>
+        <c:numFmt formatCode="General" sourceLinked="0"/>
+        <c:majorTickMark val="out"/>
+        <c:minorTickMark val="none"/>
+        <c:tickLblPos val="nextTo"/>
+        <c:spPr>
+          <a:ln w="12700" cap="flat">
+            <a:solidFill>
+              <a:srgbClr val="888888"/>
+            </a:solidFill>
+            <a:prstDash val="solid"/>
+            <a:round/>
+          </a:ln>
+        </c:spPr>
+        <c:txPr>
+          <a:bodyPr/>
+          <a:lstStyle/>
+          <a:p>
+            <a:pPr>
+              <a:defRPr sz="1100" b="0" i="0" u="none" strike="noStrike">
+                <a:solidFill>
+                  <a:srgbClr val="5B6C8F"/>
+                </a:solidFill>
+                <a:latin typeface="+mn-lt"/>
+              </a:defRPr>
+            </a:pPr>
+            <a:endParaRPr lang="en-US"/>
+          </a:p>
+        </c:txPr>
+        <c:crossAx val="2094734554"/>
+        <c:crosses val="autoZero"/>
+        <c:crossBetween val="between"/>
+      </c:valAx>
+      <c:spPr>
+        <a:noFill/>
+        <a:ln>
+          <a:noFill/>
+        </a:ln>
+        <a:effectLst/>
+      </c:spPr>
+    </c:plotArea>
+    <c:plotVisOnly val="1"/>
+    <c:dispBlanksAs val="span"/>
+  </c:chart>
+  <c:spPr>
+    <a:noFill/>
+    <a:ln>
+      <a:noFill/>
+    </a:ln>
+    <a:effectLst/>
+  </c:spPr>
+  <c:externalData r:id="rId1">
+    <c:autoUpdate val="0"/>
+  </c:externalData>
+</c:chartSpace>
+</file>
+
+<file path=ppt/charts/chart12.xml><?xml version="1.0" encoding="utf-8"?>
+<c:chartSpace xmlns:c="http://schemas.openxmlformats.org/drawingml/2006/chart" xmlns:a="http://schemas.openxmlformats.org/drawingml/2006/main" xmlns:r="http://schemas.openxmlformats.org/officeDocument/2006/relationships">
+  <c:date1904 val="0"/>
+  <c:roundedCorners val="1"/>
+  <c:chart>
+    <c:title>
+      <c:tx>
+        <c:rich>
+          <a:bodyPr/>
+          <a:lstStyle/>
+          <a:p>
+            <a:pPr>
+              <a:defRPr sz="1400" b="0" i="0" u="none" strike="noStrike">
+                <a:solidFill>
+                  <a:srgbClr val="1B2430"/>
+                </a:solidFill>
+                <a:latin typeface="+mn-lt"/>
+              </a:defRPr>
+            </a:pPr>
+            <a:r>
+              <a:rPr sz="1400" b="0" i="0" u="none" strike="noStrike">
+                <a:solidFill>
+                  <a:srgbClr val="1B2430"/>
+                </a:solidFill>
+                <a:latin typeface="+mn-lt"/>
+              </a:rPr>
+              <a:t>Mean time to first token (s)</a:t>
+            </a:r>
+          </a:p>
+        </c:rich>
+      </c:tx>
+      <c:layout/>
+      <c:overlay val="0"/>
+    </c:title>
+    <c:autoTitleDeleted val="0"/>
+    <c:plotArea>
+      <c:layout/>
+      <c:barChart>
+        <c:barDir val="col"/>
+        <c:grouping val="clustered"/>
+        <c:varyColors val="0"/>
+        <c:ser>
+          <c:idx val="0"/>
+          <c:order val="0"/>
+          <c:tx>
+            <c:strRef>
+              <c:f>Sheet1!$B$1</c:f>
+              <c:strCache>
+                <c:ptCount val="1"/>
+                <c:pt idx="0">
+                  <c:v>Mean TTFT (s)</c:v>
+                </c:pt>
+              </c:strCache>
+            </c:strRef>
+          </c:tx>
+          <c:spPr>
+            <a:solidFill>
+              <a:srgbClr val="8AC6BE"/>
+            </a:solidFill>
+            <a:effectLst/>
+          </c:spPr>
+          <c:invertIfNegative val="0"/>
+          <c:dLbls>
+            <c:numFmt formatCode="#,##0" sourceLinked="0"/>
+            <c:txPr>
+              <a:bodyPr/>
+              <a:lstStyle/>
+              <a:p>
+                <a:pPr>
+                  <a:defRPr b="0" i="0" strike="noStrike" sz="1200" u="none">
+                    <a:solidFill>
+                      <a:srgbClr val="1B2430"/>
+                    </a:solidFill>
+                    <a:latin typeface="+mn-lt"/>
+                  </a:defRPr>
+                </a:pPr>
+              </a:p>
+            </c:txPr>
+            <c:showLegendKey val="0"/>
+            <c:showVal val="1"/>
+            <c:showCatName val="0"/>
+            <c:showSerName val="0"/>
+            <c:showPercent val="0"/>
+            <c:showBubbleSize val="0"/>
+            <c:showLeaderLines val="0"/>
+          </c:dLbls>
+          <c:dPt>
+            <c:idx val="0"/>
+            <c:invertIfNegative val="0"/>
+            <c:bubble3D val="0"/>
+            <c:spPr>
+              <a:solidFill>
+                <a:srgbClr val="8AC6BE"/>
+              </a:solidFill>
+              <a:effectLst/>
+            </c:spPr>
+          </c:dPt>
+          <c:dPt>
+            <c:idx val="1"/>
+            <c:invertIfNegative val="0"/>
+            <c:bubble3D val="0"/>
+            <c:spPr>
+              <a:solidFill>
+                <a:srgbClr val="0E9F8E"/>
+              </a:solidFill>
+              <a:effectLst/>
+            </c:spPr>
+          </c:dPt>
+          <c:cat>
+            <c:multiLvlStrRef>
+              <c:f>Sheet1!$A$2:$A$3</c:f>
+              <c:multiLvlStrCache>
+                <c:ptCount val="2"/>
+                <c:lvl>
+                  <c:pt idx="0">
+                    <c:v>64 GB DRAM</c:v>
+                  </c:pt>
+                  <c:pt idx="1">
+                    <c:v>256 GB DRAM</c:v>
+                  </c:pt>
+                </c:lvl>
+              </c:multiLvlStrCache>
+            </c:multiLvlStrRef>
+          </c:cat>
+          <c:val>
+            <c:numRef>
+              <c:f>Sheet1!$B$2:$B$3</c:f>
+              <c:numCache>
+                <c:formatCode>General</c:formatCode>
+                <c:ptCount val="2"/>
+                <c:pt idx="0">
+                  <c:v>178</c:v>
+                </c:pt>
+                <c:pt idx="1">
+                  <c:v>158</c:v>
+                </c:pt>
+              </c:numCache>
+            </c:numRef>
+          </c:val>
+        </c:ser>
+        <c:dLbls>
+          <c:numFmt formatCode="#,##0" sourceLinked="0"/>
           <c:txPr>
             <a:bodyPr/>
             <a:lstStyle/>
@@ -2953,6 +4166,645 @@
 </c:chartSpace>
 </file>
 
+<file path=ppt/charts/chart9.xml><?xml version="1.0" encoding="utf-8"?>
+<c:chartSpace xmlns:c="http://schemas.openxmlformats.org/drawingml/2006/chart" xmlns:a="http://schemas.openxmlformats.org/drawingml/2006/main" xmlns:r="http://schemas.openxmlformats.org/officeDocument/2006/relationships">
+  <c:date1904 val="0"/>
+  <c:roundedCorners val="1"/>
+  <c:chart>
+    <c:title>
+      <c:tx>
+        <c:rich>
+          <a:bodyPr/>
+          <a:lstStyle/>
+          <a:p>
+            <a:pPr>
+              <a:defRPr sz="1400" b="0" i="0" u="none" strike="noStrike">
+                <a:solidFill>
+                  <a:srgbClr val="1B2430"/>
+                </a:solidFill>
+                <a:latin typeface="+mn-lt"/>
+              </a:defRPr>
+            </a:pPr>
+            <a:r>
+              <a:rPr sz="1400" b="0" i="0" u="none" strike="noStrike">
+                <a:solidFill>
+                  <a:srgbClr val="1B2430"/>
+                </a:solidFill>
+                <a:latin typeface="+mn-lt"/>
+              </a:rPr>
+              <a:t>Prompt tokens served from DRAM / NVMe (%)</a:t>
+            </a:r>
+          </a:p>
+        </c:rich>
+      </c:tx>
+      <c:layout/>
+      <c:overlay val="0"/>
+    </c:title>
+    <c:autoTitleDeleted val="0"/>
+    <c:plotArea>
+      <c:layout/>
+      <c:lineChart>
+        <c:varyColors val="0"/>
+        <c:ser>
+          <c:idx val="0"/>
+          <c:order val="0"/>
+          <c:tx>
+            <c:strRef>
+              <c:f>Sheet1!$B$1</c:f>
+              <c:strCache>
+                <c:ptCount val="1"/>
+                <c:pt idx="0">
+                  <c:v>vLLM + LMCache (DRAM + NVMe)</c:v>
+                </c:pt>
+              </c:strCache>
+            </c:strRef>
+          </c:tx>
+          <c:spPr>
+            <a:solidFill>
+              <a:srgbClr val="5B6C8F"/>
+            </a:solidFill>
+            <a:ln w="38100" cap="flat">
+              <a:solidFill>
+                <a:srgbClr val="5B6C8F"/>
+              </a:solidFill>
+              <a:prstDash val="solid"/>
+              <a:round/>
+            </a:ln>
+            <a:effectLst/>
+          </c:spPr>
+          <c:invertIfNegative val="0"/>
+          <c:dLbls>
+            <c:numFmt formatCode="#,##0" sourceLinked="0"/>
+            <c:txPr>
+              <a:bodyPr/>
+              <a:lstStyle/>
+              <a:p>
+                <a:pPr>
+                  <a:defRPr b="0" i="0" strike="noStrike" sz="1200" u="none">
+                    <a:solidFill>
+                      <a:srgbClr val="1B2430"/>
+                    </a:solidFill>
+                    <a:latin typeface="+mn-lt"/>
+                  </a:defRPr>
+                </a:pPr>
+              </a:p>
+            </c:txPr>
+            <c:showLegendKey val="0"/>
+            <c:showVal val="0"/>
+            <c:showCatName val="0"/>
+            <c:showSerName val="0"/>
+            <c:showPercent val="0"/>
+            <c:showBubbleSize val="0"/>
+            <c:showLeaderLines val="0"/>
+          </c:dLbls>
+          <c:marker>
+            <c:symbol val="none"/>
+            <c:size val="6"/>
+            <c:spPr>
+              <a:solidFill>
+                <a:srgbClr val="5B6C8F"/>
+              </a:solidFill>
+              <a:ln w="9525" cap="flat">
+                <a:solidFill>
+                  <a:srgbClr val="5B6C8F"/>
+                </a:solidFill>
+                <a:prstDash val="solid"/>
+                <a:round/>
+              </a:ln>
+              <a:effectLst/>
+            </c:spPr>
+          </c:marker>
+          <c:cat>
+            <c:multiLvlStrRef>
+              <c:f>Sheet1!$A$2:$A$20</c:f>
+              <c:multiLvlStrCache>
+                <c:ptCount val="19"/>
+                <c:lvl>
+                  <c:pt idx="0">
+                    <c:v>0</c:v>
+                  </c:pt>
+                  <c:pt idx="1">
+                    <c:v>5</c:v>
+                  </c:pt>
+                  <c:pt idx="2">
+                    <c:v>10</c:v>
+                  </c:pt>
+                  <c:pt idx="3">
+                    <c:v>15</c:v>
+                  </c:pt>
+                  <c:pt idx="4">
+                    <c:v>20</c:v>
+                  </c:pt>
+                  <c:pt idx="5">
+                    <c:v>25</c:v>
+                  </c:pt>
+                  <c:pt idx="6">
+                    <c:v>30</c:v>
+                  </c:pt>
+                  <c:pt idx="7">
+                    <c:v>35</c:v>
+                  </c:pt>
+                  <c:pt idx="8">
+                    <c:v>40</c:v>
+                  </c:pt>
+                  <c:pt idx="9">
+                    <c:v>45</c:v>
+                  </c:pt>
+                  <c:pt idx="10">
+                    <c:v>50</c:v>
+                  </c:pt>
+                  <c:pt idx="11">
+                    <c:v>55</c:v>
+                  </c:pt>
+                  <c:pt idx="12">
+                    <c:v>60</c:v>
+                  </c:pt>
+                  <c:pt idx="13">
+                    <c:v>65</c:v>
+                  </c:pt>
+                  <c:pt idx="14">
+                    <c:v>70</c:v>
+                  </c:pt>
+                  <c:pt idx="15">
+                    <c:v>75</c:v>
+                  </c:pt>
+                  <c:pt idx="16">
+                    <c:v>80</c:v>
+                  </c:pt>
+                  <c:pt idx="17">
+                    <c:v>85</c:v>
+                  </c:pt>
+                  <c:pt idx="18">
+                    <c:v>90</c:v>
+                  </c:pt>
+                </c:lvl>
+              </c:multiLvlStrCache>
+            </c:multiLvlStrRef>
+          </c:cat>
+          <c:val>
+            <c:numRef>
+              <c:f>Sheet1!$B$2:$B$20</c:f>
+              <c:numCache>
+                <c:formatCode>General</c:formatCode>
+                <c:ptCount val="19"/>
+                <c:pt idx="0">
+                  <c:v>1</c:v>
+                </c:pt>
+                <c:pt idx="1">
+                  <c:v>57</c:v>
+                </c:pt>
+                <c:pt idx="2">
+                  <c:v>83</c:v>
+                </c:pt>
+                <c:pt idx="3">
+                  <c:v>86</c:v>
+                </c:pt>
+                <c:pt idx="4">
+                  <c:v>89</c:v>
+                </c:pt>
+                <c:pt idx="5">
+                  <c:v>91</c:v>
+                </c:pt>
+                <c:pt idx="6">
+                  <c:v>91</c:v>
+                </c:pt>
+                <c:pt idx="7">
+                  <c:v>89</c:v>
+                </c:pt>
+                <c:pt idx="8">
+                  <c:v>85</c:v>
+                </c:pt>
+                <c:pt idx="9">
+                  <c:v>81</c:v>
+                </c:pt>
+                <c:pt idx="10">
+                  <c:v>77</c:v>
+                </c:pt>
+                <c:pt idx="11">
+                  <c:v>74</c:v>
+                </c:pt>
+                <c:pt idx="12">
+                  <c:v>70</c:v>
+                </c:pt>
+                <c:pt idx="13">
+                  <c:v>65</c:v>
+                </c:pt>
+                <c:pt idx="14">
+                  <c:v>59</c:v>
+                </c:pt>
+                <c:pt idx="15">
+                  <c:v>55</c:v>
+                </c:pt>
+                <c:pt idx="16">
+                  <c:v>51</c:v>
+                </c:pt>
+                <c:pt idx="17">
+                  <c:v>47</c:v>
+                </c:pt>
+                <c:pt idx="18">
+                  <c:v>47</c:v>
+                </c:pt>
+              </c:numCache>
+            </c:numRef>
+          </c:val>
+          <c:smooth val="0"/>
+        </c:ser>
+        <c:ser>
+          <c:idx val="1"/>
+          <c:order val="1"/>
+          <c:tx>
+            <c:strRef>
+              <c:f>Sheet1!$C$1</c:f>
+              <c:strCache>
+                <c:ptCount val="1"/>
+                <c:pt idx="0">
+                  <c:v>vLLM + LifeboatCache</c:v>
+                </c:pt>
+              </c:strCache>
+            </c:strRef>
+          </c:tx>
+          <c:spPr>
+            <a:solidFill>
+              <a:srgbClr val="0E9F8E"/>
+            </a:solidFill>
+            <a:ln w="38100" cap="flat">
+              <a:solidFill>
+                <a:srgbClr val="0E9F8E"/>
+              </a:solidFill>
+              <a:prstDash val="solid"/>
+              <a:round/>
+            </a:ln>
+            <a:effectLst/>
+          </c:spPr>
+          <c:invertIfNegative val="0"/>
+          <c:dLbls>
+            <c:numFmt formatCode="#,##0" sourceLinked="0"/>
+            <c:txPr>
+              <a:bodyPr/>
+              <a:lstStyle/>
+              <a:p>
+                <a:pPr>
+                  <a:defRPr b="0" i="0" strike="noStrike" sz="1200" u="none">
+                    <a:solidFill>
+                      <a:srgbClr val="1B2430"/>
+                    </a:solidFill>
+                    <a:latin typeface="+mn-lt"/>
+                  </a:defRPr>
+                </a:pPr>
+              </a:p>
+            </c:txPr>
+            <c:showLegendKey val="0"/>
+            <c:showVal val="0"/>
+            <c:showCatName val="0"/>
+            <c:showSerName val="0"/>
+            <c:showPercent val="0"/>
+            <c:showBubbleSize val="0"/>
+            <c:showLeaderLines val="0"/>
+          </c:dLbls>
+          <c:marker>
+            <c:symbol val="none"/>
+            <c:size val="6"/>
+            <c:spPr>
+              <a:solidFill>
+                <a:srgbClr val="0E9F8E"/>
+              </a:solidFill>
+              <a:ln w="9525" cap="flat">
+                <a:solidFill>
+                  <a:srgbClr val="0E9F8E"/>
+                </a:solidFill>
+                <a:prstDash val="solid"/>
+                <a:round/>
+              </a:ln>
+              <a:effectLst/>
+            </c:spPr>
+          </c:marker>
+          <c:cat>
+            <c:multiLvlStrRef>
+              <c:f>Sheet1!$A$2:$A$20</c:f>
+              <c:multiLvlStrCache>
+                <c:ptCount val="19"/>
+                <c:lvl>
+                  <c:pt idx="0">
+                    <c:v>0</c:v>
+                  </c:pt>
+                  <c:pt idx="1">
+                    <c:v>5</c:v>
+                  </c:pt>
+                  <c:pt idx="2">
+                    <c:v>10</c:v>
+                  </c:pt>
+                  <c:pt idx="3">
+                    <c:v>15</c:v>
+                  </c:pt>
+                  <c:pt idx="4">
+                    <c:v>20</c:v>
+                  </c:pt>
+                  <c:pt idx="5">
+                    <c:v>25</c:v>
+                  </c:pt>
+                  <c:pt idx="6">
+                    <c:v>30</c:v>
+                  </c:pt>
+                  <c:pt idx="7">
+                    <c:v>35</c:v>
+                  </c:pt>
+                  <c:pt idx="8">
+                    <c:v>40</c:v>
+                  </c:pt>
+                  <c:pt idx="9">
+                    <c:v>45</c:v>
+                  </c:pt>
+                  <c:pt idx="10">
+                    <c:v>50</c:v>
+                  </c:pt>
+                  <c:pt idx="11">
+                    <c:v>55</c:v>
+                  </c:pt>
+                  <c:pt idx="12">
+                    <c:v>60</c:v>
+                  </c:pt>
+                  <c:pt idx="13">
+                    <c:v>65</c:v>
+                  </c:pt>
+                  <c:pt idx="14">
+                    <c:v>70</c:v>
+                  </c:pt>
+                  <c:pt idx="15">
+                    <c:v>75</c:v>
+                  </c:pt>
+                  <c:pt idx="16">
+                    <c:v>80</c:v>
+                  </c:pt>
+                  <c:pt idx="17">
+                    <c:v>85</c:v>
+                  </c:pt>
+                  <c:pt idx="18">
+                    <c:v>90</c:v>
+                  </c:pt>
+                </c:lvl>
+              </c:multiLvlStrCache>
+            </c:multiLvlStrRef>
+          </c:cat>
+          <c:val>
+            <c:numRef>
+              <c:f>Sheet1!$C$2:$C$20</c:f>
+              <c:numCache>
+                <c:formatCode>General</c:formatCode>
+                <c:ptCount val="19"/>
+                <c:pt idx="0">
+                  <c:v>1</c:v>
+                </c:pt>
+                <c:pt idx="1">
+                  <c:v>57</c:v>
+                </c:pt>
+                <c:pt idx="2">
+                  <c:v>81</c:v>
+                </c:pt>
+                <c:pt idx="3">
+                  <c:v>84</c:v>
+                </c:pt>
+                <c:pt idx="4">
+                  <c:v>87</c:v>
+                </c:pt>
+                <c:pt idx="5">
+                  <c:v>91</c:v>
+                </c:pt>
+                <c:pt idx="6">
+                  <c:v>92</c:v>
+                </c:pt>
+                <c:pt idx="7">
+                  <c:v>92</c:v>
+                </c:pt>
+                <c:pt idx="8">
+                  <c:v>92</c:v>
+                </c:pt>
+                <c:pt idx="9">
+                  <c:v>91</c:v>
+                </c:pt>
+                <c:pt idx="10">
+                  <c:v>91</c:v>
+                </c:pt>
+                <c:pt idx="11">
+                  <c:v>92</c:v>
+                </c:pt>
+                <c:pt idx="12">
+                  <c:v>91</c:v>
+                </c:pt>
+                <c:pt idx="13">
+                  <c:v>92</c:v>
+                </c:pt>
+                <c:pt idx="14">
+                  <c:v>93</c:v>
+                </c:pt>
+                <c:pt idx="15">
+                  <c:v>94</c:v>
+                </c:pt>
+                <c:pt idx="16">
+                  <c:v/>
+                </c:pt>
+                <c:pt idx="17">
+                  <c:v/>
+                </c:pt>
+                <c:pt idx="18">
+                  <c:v/>
+                </c:pt>
+              </c:numCache>
+            </c:numRef>
+          </c:val>
+          <c:smooth val="0"/>
+        </c:ser>
+        <c:dLbls>
+          <c:numFmt formatCode="#,##0" sourceLinked="0"/>
+          <c:txPr>
+            <a:bodyPr/>
+            <a:lstStyle/>
+            <a:p>
+              <a:pPr>
+                <a:defRPr b="0" i="0" strike="noStrike" sz="1200" u="none">
+                  <a:solidFill>
+                    <a:srgbClr val="1B2430"/>
+                  </a:solidFill>
+                  <a:latin typeface="+mn-lt"/>
+                </a:defRPr>
+              </a:pPr>
+            </a:p>
+          </c:txPr>
+          <c:showLegendKey val="0"/>
+          <c:showVal val="0"/>
+          <c:showCatName val="0"/>
+          <c:showSerName val="0"/>
+          <c:showPercent val="0"/>
+          <c:showBubbleSize val="0"/>
+          <c:showLeaderLines val="0"/>
+        </c:dLbls>
+        <c:marker val="1"/>
+        <c:axId val="2094734554"/>
+        <c:axId val="2094734552"/>
+        <c:axId val="2094734556"/>
+      </c:lineChart>
+      <c:catAx>
+        <c:axId val="2094734554"/>
+        <c:scaling>
+          <c:orientation val="minMax"/>
+        </c:scaling>
+        <c:delete val="0"/>
+        <c:axPos val="b"/>
+        <c:title>
+          <c:tx>
+            <c:rich>
+              <a:bodyPr/>
+              <a:lstStyle/>
+              <a:p>
+                <a:pPr>
+                  <a:defRPr b="0" i="0" u="none" strike="noStrike">
+                    <a:solidFill>
+                      <a:srgbClr val="000000"/>
+                    </a:solidFill>
+                    <a:latin typeface="Arial"/>
+                  </a:defRPr>
+                </a:pPr>
+                <a:r>
+                  <a:rPr b="0" i="0" u="none" strike="noStrike">
+                    <a:solidFill>
+                      <a:srgbClr val="000000"/>
+                    </a:solidFill>
+                    <a:latin typeface="Arial"/>
+                  </a:rPr>
+                  <a:t>minutes</a:t>
+                </a:r>
+              </a:p>
+            </c:rich>
+          </c:tx>
+          <c:layout/>
+          <c:overlay val="0"/>
+        </c:title>
+        <c:numFmt formatCode="General" sourceLinked="1"/>
+        <c:majorTickMark val="out"/>
+        <c:minorTickMark val="none"/>
+        <c:tickLblPos val="low"/>
+        <c:spPr>
+          <a:ln w="12700" cap="flat">
+            <a:solidFill>
+              <a:srgbClr val="888888"/>
+            </a:solidFill>
+            <a:prstDash val="solid"/>
+            <a:round/>
+          </a:ln>
+        </c:spPr>
+        <c:txPr>
+          <a:bodyPr/>
+          <a:lstStyle/>
+          <a:p>
+            <a:pPr>
+              <a:defRPr sz="1200" b="0" i="0" u="none" strike="noStrike">
+                <a:solidFill>
+                  <a:srgbClr val="1B2430"/>
+                </a:solidFill>
+                <a:latin typeface="+mn-lt"/>
+              </a:defRPr>
+            </a:pPr>
+            <a:endParaRPr lang="en-US"/>
+          </a:p>
+        </c:txPr>
+        <c:crossAx val="2094734552"/>
+        <c:crosses val="autoZero"/>
+        <c:auto val="1"/>
+        <c:lblAlgn val="ctr"/>
+        <c:noMultiLvlLbl val="1"/>
+      </c:catAx>
+      <c:valAx>
+        <c:axId val="2094734552"/>
+        <c:scaling>
+          <c:orientation val="minMax"/>
+          <c:max val="100"/>
+          <c:min val="0"/>
+        </c:scaling>
+        <c:delete val="0"/>
+        <c:axPos val="l"/>
+        <c:majorGridlines>
+          <c:spPr>
+            <a:ln w="9525" cap="flat">
+              <a:solidFill>
+                <a:srgbClr val="D9E0E7"/>
+              </a:solidFill>
+              <a:prstDash val="solid"/>
+              <a:round/>
+            </a:ln>
+          </c:spPr>
+        </c:majorGridlines>
+        <c:numFmt formatCode="General" sourceLinked="0"/>
+        <c:majorTickMark val="out"/>
+        <c:minorTickMark val="none"/>
+        <c:tickLblPos val="nextTo"/>
+        <c:spPr>
+          <a:ln w="12700" cap="flat">
+            <a:solidFill>
+              <a:srgbClr val="888888"/>
+            </a:solidFill>
+            <a:prstDash val="solid"/>
+            <a:round/>
+          </a:ln>
+        </c:spPr>
+        <c:txPr>
+          <a:bodyPr/>
+          <a:lstStyle/>
+          <a:p>
+            <a:pPr>
+              <a:defRPr sz="1100" b="0" i="0" u="none" strike="noStrike">
+                <a:solidFill>
+                  <a:srgbClr val="5B6C8F"/>
+                </a:solidFill>
+                <a:latin typeface="+mn-lt"/>
+              </a:defRPr>
+            </a:pPr>
+            <a:endParaRPr lang="en-US"/>
+          </a:p>
+        </c:txPr>
+        <c:crossAx val="2094734554"/>
+        <c:crosses val="autoZero"/>
+        <c:crossBetween val="between"/>
+      </c:valAx>
+      <c:spPr>
+        <a:noFill/>
+        <a:ln>
+          <a:noFill/>
+        </a:ln>
+        <a:effectLst/>
+      </c:spPr>
+    </c:plotArea>
+    <c:legend>
+      <c:legendPos val="b"/>
+      <c:overlay val="0"/>
+      <c:txPr>
+        <a:bodyPr/>
+        <a:lstStyle/>
+        <a:p>
+          <a:pPr>
+            <a:defRPr sz="1100">
+              <a:latin typeface="+mn-lt"/>
+              <a:cs typeface="+mn-lt"/>
+            </a:defRPr>
+          </a:pPr>
+          <a:endParaRPr lang="en-US"/>
+        </a:p>
+      </c:txPr>
+    </c:legend>
+    <c:plotVisOnly val="1"/>
+    <c:dispBlanksAs val="span"/>
+  </c:chart>
+  <c:spPr>
+    <a:noFill/>
+    <a:ln>
+      <a:noFill/>
+    </a:ln>
+    <a:effectLst/>
+  </c:spPr>
+  <c:externalData r:id="rId1">
+    <c:autoUpdate val="0"/>
+  </c:externalData>
+</c:chartSpace>
+</file>
+
 <file path=ppt/notesMasters/notesMaster1.xml><?xml version="1.0" encoding="utf-8"?>
 <p:notesMaster xmlns:a="http://schemas.openxmlformats.org/drawingml/2006/main" xmlns:r="http://schemas.openxmlformats.org/officeDocument/2006/relationships" xmlns:p="http://schemas.openxmlformats.org/presentationml/2006/main">
   <p:cSld>
@@ -3724,6 +5576,270 @@
             <a:fld id="{F7021451-1387-4CA6-816F-3879F97B5CBC}" type="slidenum">
               <a:rPr lang="en-US"/>
               <a:t>13</a:t>
+            </a:fld>
+            <a:endParaRPr lang="en-US"/>
+          </a:p>
+        </p:txBody>
+      </p:sp>
+    </p:spTree>
+    <p:extLst>
+      <p:ext uri="{BB962C8B-B14F-4D97-AF65-F5344CB8AC3E}">
+        <p14:creationId xmlns:p14="http://schemas.microsoft.com/office/powerpoint/2010/main" val="1024086991"/>
+      </p:ext>
+    </p:extLst>
+  </p:cSld>
+  <p:clrMapOvr>
+    <a:masterClrMapping/>
+  </p:clrMapOvr>
+</p:notes>
+</file>
+
+<file path=ppt/notesSlides/notesSlide14.xml><?xml version="1.0" encoding="utf-8"?>
+<p:notes xmlns:a="http://schemas.openxmlformats.org/drawingml/2006/main" xmlns:r="http://schemas.openxmlformats.org/officeDocument/2006/relationships" xmlns:p="http://schemas.openxmlformats.org/presentationml/2006/main">
+  <p:cSld>
+    <p:spTree>
+      <p:nvGrpSpPr>
+        <p:cNvPr id="1" name=""/>
+        <p:cNvGrpSpPr/>
+        <p:nvPr/>
+      </p:nvGrpSpPr>
+      <p:grpSpPr>
+        <a:xfrm>
+          <a:off x="0" y="0"/>
+          <a:ext cx="0" cy="0"/>
+          <a:chOff x="0" y="0"/>
+          <a:chExt cx="0" cy="0"/>
+        </a:xfrm>
+      </p:grpSpPr>
+      <p:sp>
+        <p:nvSpPr>
+          <p:cNvPr id="2" name="Slide Image Placeholder 1"/>
+          <p:cNvSpPr>
+            <a:spLocks noGrp="1" noRot="1" noChangeAspect="1"/>
+          </p:cNvSpPr>
+          <p:nvPr>
+            <p:ph type="sldImg"/>
+          </p:nvPr>
+        </p:nvSpPr>
+        <p:spPr/>
+      </p:sp>
+      <p:sp>
+        <p:nvSpPr>
+          <p:cNvPr id="3" name="Notes Placeholder 2"/>
+          <p:cNvSpPr>
+            <a:spLocks noGrp="1"/>
+          </p:cNvSpPr>
+          <p:nvPr>
+            <p:ph type="body" idx="1"/>
+          </p:nvPr>
+        </p:nvSpPr>
+        <p:spPr/>
+        <p:txBody>
+          <a:bodyPr/>
+          <a:lstStyle/>
+          <a:p>
+            <a:r>
+              <a:rPr lang="en-US" dirty="0"/>
+              <a:t/>
+            </a:r>
+            <a:endParaRPr lang="en-US" dirty="0"/>
+          </a:p>
+        </p:txBody>
+      </p:sp>
+      <p:sp>
+        <p:nvSpPr>
+          <p:cNvPr id="4" name="Slide Number Placeholder 3"/>
+          <p:cNvSpPr>
+            <a:spLocks noGrp="1"/>
+          </p:cNvSpPr>
+          <p:nvPr>
+            <p:ph type="sldNum" sz="quarter" idx="10"/>
+          </p:nvPr>
+        </p:nvSpPr>
+        <p:spPr/>
+        <p:txBody>
+          <a:bodyPr/>
+          <a:lstStyle/>
+          <a:p>
+            <a:fld id="{F7021451-1387-4CA6-816F-3879F97B5CBC}" type="slidenum">
+              <a:rPr lang="en-US"/>
+              <a:t>14</a:t>
+            </a:fld>
+            <a:endParaRPr lang="en-US"/>
+          </a:p>
+        </p:txBody>
+      </p:sp>
+    </p:spTree>
+    <p:extLst>
+      <p:ext uri="{BB962C8B-B14F-4D97-AF65-F5344CB8AC3E}">
+        <p14:creationId xmlns:p14="http://schemas.microsoft.com/office/powerpoint/2010/main" val="1024086991"/>
+      </p:ext>
+    </p:extLst>
+  </p:cSld>
+  <p:clrMapOvr>
+    <a:masterClrMapping/>
+  </p:clrMapOvr>
+</p:notes>
+</file>
+
+<file path=ppt/notesSlides/notesSlide15.xml><?xml version="1.0" encoding="utf-8"?>
+<p:notes xmlns:a="http://schemas.openxmlformats.org/drawingml/2006/main" xmlns:r="http://schemas.openxmlformats.org/officeDocument/2006/relationships" xmlns:p="http://schemas.openxmlformats.org/presentationml/2006/main">
+  <p:cSld>
+    <p:spTree>
+      <p:nvGrpSpPr>
+        <p:cNvPr id="1" name=""/>
+        <p:cNvGrpSpPr/>
+        <p:nvPr/>
+      </p:nvGrpSpPr>
+      <p:grpSpPr>
+        <a:xfrm>
+          <a:off x="0" y="0"/>
+          <a:ext cx="0" cy="0"/>
+          <a:chOff x="0" y="0"/>
+          <a:chExt cx="0" cy="0"/>
+        </a:xfrm>
+      </p:grpSpPr>
+      <p:sp>
+        <p:nvSpPr>
+          <p:cNvPr id="2" name="Slide Image Placeholder 1"/>
+          <p:cNvSpPr>
+            <a:spLocks noGrp="1" noRot="1" noChangeAspect="1"/>
+          </p:cNvSpPr>
+          <p:nvPr>
+            <p:ph type="sldImg"/>
+          </p:nvPr>
+        </p:nvSpPr>
+        <p:spPr/>
+      </p:sp>
+      <p:sp>
+        <p:nvSpPr>
+          <p:cNvPr id="3" name="Notes Placeholder 2"/>
+          <p:cNvSpPr>
+            <a:spLocks noGrp="1"/>
+          </p:cNvSpPr>
+          <p:nvPr>
+            <p:ph type="body" idx="1"/>
+          </p:nvPr>
+        </p:nvSpPr>
+        <p:spPr/>
+        <p:txBody>
+          <a:bodyPr/>
+          <a:lstStyle/>
+          <a:p>
+            <a:r>
+              <a:rPr lang="en-US" dirty="0"/>
+              <a:t/>
+            </a:r>
+            <a:endParaRPr lang="en-US" dirty="0"/>
+          </a:p>
+        </p:txBody>
+      </p:sp>
+      <p:sp>
+        <p:nvSpPr>
+          <p:cNvPr id="4" name="Slide Number Placeholder 3"/>
+          <p:cNvSpPr>
+            <a:spLocks noGrp="1"/>
+          </p:cNvSpPr>
+          <p:nvPr>
+            <p:ph type="sldNum" sz="quarter" idx="10"/>
+          </p:nvPr>
+        </p:nvSpPr>
+        <p:spPr/>
+        <p:txBody>
+          <a:bodyPr/>
+          <a:lstStyle/>
+          <a:p>
+            <a:fld id="{F7021451-1387-4CA6-816F-3879F97B5CBC}" type="slidenum">
+              <a:rPr lang="en-US"/>
+              <a:t>15</a:t>
+            </a:fld>
+            <a:endParaRPr lang="en-US"/>
+          </a:p>
+        </p:txBody>
+      </p:sp>
+    </p:spTree>
+    <p:extLst>
+      <p:ext uri="{BB962C8B-B14F-4D97-AF65-F5344CB8AC3E}">
+        <p14:creationId xmlns:p14="http://schemas.microsoft.com/office/powerpoint/2010/main" val="1024086991"/>
+      </p:ext>
+    </p:extLst>
+  </p:cSld>
+  <p:clrMapOvr>
+    <a:masterClrMapping/>
+  </p:clrMapOvr>
+</p:notes>
+</file>
+
+<file path=ppt/notesSlides/notesSlide16.xml><?xml version="1.0" encoding="utf-8"?>
+<p:notes xmlns:a="http://schemas.openxmlformats.org/drawingml/2006/main" xmlns:r="http://schemas.openxmlformats.org/officeDocument/2006/relationships" xmlns:p="http://schemas.openxmlformats.org/presentationml/2006/main">
+  <p:cSld>
+    <p:spTree>
+      <p:nvGrpSpPr>
+        <p:cNvPr id="1" name=""/>
+        <p:cNvGrpSpPr/>
+        <p:nvPr/>
+      </p:nvGrpSpPr>
+      <p:grpSpPr>
+        <a:xfrm>
+          <a:off x="0" y="0"/>
+          <a:ext cx="0" cy="0"/>
+          <a:chOff x="0" y="0"/>
+          <a:chExt cx="0" cy="0"/>
+        </a:xfrm>
+      </p:grpSpPr>
+      <p:sp>
+        <p:nvSpPr>
+          <p:cNvPr id="2" name="Slide Image Placeholder 1"/>
+          <p:cNvSpPr>
+            <a:spLocks noGrp="1" noRot="1" noChangeAspect="1"/>
+          </p:cNvSpPr>
+          <p:nvPr>
+            <p:ph type="sldImg"/>
+          </p:nvPr>
+        </p:nvSpPr>
+        <p:spPr/>
+      </p:sp>
+      <p:sp>
+        <p:nvSpPr>
+          <p:cNvPr id="3" name="Notes Placeholder 2"/>
+          <p:cNvSpPr>
+            <a:spLocks noGrp="1"/>
+          </p:cNvSpPr>
+          <p:nvPr>
+            <p:ph type="body" idx="1"/>
+          </p:nvPr>
+        </p:nvSpPr>
+        <p:spPr/>
+        <p:txBody>
+          <a:bodyPr/>
+          <a:lstStyle/>
+          <a:p>
+            <a:r>
+              <a:rPr lang="en-US" dirty="0"/>
+              <a:t/>
+            </a:r>
+            <a:endParaRPr lang="en-US" dirty="0"/>
+          </a:p>
+        </p:txBody>
+      </p:sp>
+      <p:sp>
+        <p:nvSpPr>
+          <p:cNvPr id="4" name="Slide Number Placeholder 3"/>
+          <p:cNvSpPr>
+            <a:spLocks noGrp="1"/>
+          </p:cNvSpPr>
+          <p:nvPr>
+            <p:ph type="sldNum" sz="quarter" idx="10"/>
+          </p:nvPr>
+        </p:nvSpPr>
+        <p:spPr/>
+        <p:txBody>
+          <a:bodyPr/>
+          <a:lstStyle/>
+          <a:p>
+            <a:fld id="{F7021451-1387-4CA6-816F-3879F97B5CBC}" type="slidenum">
+              <a:rPr lang="en-US"/>
+              <a:t>16</a:t>
             </a:fld>
             <a:endParaRPr lang="en-US"/>
           </a:p>
@@ -5238,6 +7354,895 @@
                 <a:ea typeface="Cambria" pitchFamily="34" charset="-122"/>
                 <a:cs typeface="Cambria" pitchFamily="34" charset="-120"/>
               </a:rPr>
+              <a:t>Long agent sessions at 256 and 512 agents</a:t>
+            </a:r>
+            <a:endParaRPr lang="en-US" sz="3200" dirty="0"/>
+          </a:p>
+        </p:txBody>
+      </p:sp>
+      <p:sp>
+        <p:nvSpPr>
+          <p:cNvPr id="3" name="h256 card"/>
+          <p:cNvSpPr/>
+          <p:nvPr/>
+        </p:nvSpPr>
+        <p:spPr>
+          <a:xfrm>
+            <a:off x="548640" y="1463040"/>
+            <a:ext cx="3520440" cy="2103120"/>
+          </a:xfrm>
+          <a:prstGeom prst="roundRect">
+            <a:avLst>
+              <a:gd name="adj" fmla="val 5217"/>
+            </a:avLst>
+          </a:prstGeom>
+          <a:solidFill>
+            <a:srgbClr val="EEF3F7"/>
+          </a:solidFill>
+          <a:ln w="12700">
+            <a:solidFill>
+              <a:srgbClr val="EEF3F7"/>
+            </a:solidFill>
+            <a:prstDash val="solid"/>
+          </a:ln>
+        </p:spPr>
+      </p:sp>
+      <p:sp>
+        <p:nvSpPr>
+          <p:cNvPr id="4" name="h256 value"/>
+          <p:cNvSpPr txBox="1"/>
+          <p:nvPr/>
+        </p:nvSpPr>
+        <p:spPr>
+          <a:xfrm>
+            <a:off x="822960" y="1691640"/>
+            <a:ext cx="2971800" cy="914400"/>
+          </a:xfrm>
+          <a:prstGeom prst="rect">
+            <a:avLst/>
+          </a:prstGeom>
+          <a:noFill/>
+          <a:ln/>
+        </p:spPr>
+        <p:txBody>
+          <a:bodyPr wrap="square" lIns="0" tIns="0" rIns="0" bIns="0" rtlCol="0" anchor="ctr"/>
+          <a:lstStyle/>
+          <a:p>
+            <a:pPr indent="0" marL="0">
+              <a:buNone/>
+            </a:pPr>
+            <a:r>
+              <a:rPr lang="en-US" sz="4800" b="1" dirty="0">
+                <a:solidFill>
+                  <a:schemeClr val="accent1"/>
+                </a:solidFill>
+                <a:latin typeface="Cambria" pitchFamily="34" charset="0"/>
+                <a:ea typeface="Cambria" pitchFamily="34" charset="-122"/>
+                <a:cs typeface="Cambria" pitchFamily="34" charset="-120"/>
+              </a:rPr>
+              <a:t>223 tok/s</a:t>
+            </a:r>
+            <a:endParaRPr lang="en-US" sz="4800" dirty="0"/>
+          </a:p>
+        </p:txBody>
+      </p:sp>
+      <p:sp>
+        <p:nvSpPr>
+          <p:cNvPr id="5" name="h256 label"/>
+          <p:cNvSpPr txBox="1"/>
+          <p:nvPr/>
+        </p:nvSpPr>
+        <p:spPr>
+          <a:xfrm>
+            <a:off x="822960" y="2606040"/>
+            <a:ext cx="2971800" cy="868680"/>
+          </a:xfrm>
+          <a:prstGeom prst="rect">
+            <a:avLst/>
+          </a:prstGeom>
+          <a:noFill/>
+          <a:ln/>
+        </p:spPr>
+        <p:txBody>
+          <a:bodyPr wrap="square" lIns="0" tIns="0" rIns="0" bIns="0" rtlCol="0" anchor="t"/>
+          <a:lstStyle/>
+          <a:p>
+            <a:pPr indent="0" marL="0">
+              <a:buNone/>
+            </a:pPr>
+            <a:r>
+              <a:rPr lang="en-US" sz="1600" b="1" dirty="0">
+                <a:solidFill>
+                  <a:schemeClr val="tx1"/>
+                </a:solidFill>
+              </a:rPr>
+              <a:t>256 agents</a:t>
+            </a:r>
+            <a:endParaRPr lang="en-US" sz="1600" dirty="0"/>
+          </a:p>
+          <a:p>
+            <a:pPr indent="0" marL="0">
+              <a:buNone/>
+            </a:pPr>
+            <a:r>
+              <a:rPr lang="en-US" sz="1300" dirty="0">
+                <a:solidFill>
+                  <a:schemeClr val="accent2"/>
+                </a:solidFill>
+              </a:rPr>
+              <a:t>158 s mean TTFT, 89% from cache</a:t>
+            </a:r>
+            <a:endParaRPr lang="en-US" sz="1600" dirty="0"/>
+          </a:p>
+        </p:txBody>
+      </p:sp>
+      <p:sp>
+        <p:nvSpPr>
+          <p:cNvPr id="6" name="h512 card"/>
+          <p:cNvSpPr/>
+          <p:nvPr/>
+        </p:nvSpPr>
+        <p:spPr>
+          <a:xfrm>
+            <a:off x="4343400" y="1463040"/>
+            <a:ext cx="3520440" cy="2103120"/>
+          </a:xfrm>
+          <a:prstGeom prst="roundRect">
+            <a:avLst>
+              <a:gd name="adj" fmla="val 5217"/>
+            </a:avLst>
+          </a:prstGeom>
+          <a:solidFill>
+            <a:srgbClr val="EEF3F7"/>
+          </a:solidFill>
+          <a:ln w="12700">
+            <a:solidFill>
+              <a:srgbClr val="EEF3F7"/>
+            </a:solidFill>
+            <a:prstDash val="solid"/>
+          </a:ln>
+        </p:spPr>
+      </p:sp>
+      <p:sp>
+        <p:nvSpPr>
+          <p:cNvPr id="7" name="h512 value"/>
+          <p:cNvSpPr txBox="1"/>
+          <p:nvPr/>
+        </p:nvSpPr>
+        <p:spPr>
+          <a:xfrm>
+            <a:off x="4617720" y="1691640"/>
+            <a:ext cx="2971800" cy="914400"/>
+          </a:xfrm>
+          <a:prstGeom prst="rect">
+            <a:avLst/>
+          </a:prstGeom>
+          <a:noFill/>
+          <a:ln/>
+        </p:spPr>
+        <p:txBody>
+          <a:bodyPr wrap="square" lIns="0" tIns="0" rIns="0" bIns="0" rtlCol="0" anchor="ctr"/>
+          <a:lstStyle/>
+          <a:p>
+            <a:pPr indent="0" marL="0">
+              <a:buNone/>
+            </a:pPr>
+            <a:r>
+              <a:rPr lang="en-US" sz="4800" b="1" dirty="0">
+                <a:solidFill>
+                  <a:schemeClr val="accent1"/>
+                </a:solidFill>
+                <a:latin typeface="Cambria" pitchFamily="34" charset="0"/>
+                <a:ea typeface="Cambria" pitchFamily="34" charset="-122"/>
+                <a:cs typeface="Cambria" pitchFamily="34" charset="-120"/>
+              </a:rPr>
+              <a:t>122 tok/s</a:t>
+            </a:r>
+            <a:endParaRPr lang="en-US" sz="4800" dirty="0"/>
+          </a:p>
+        </p:txBody>
+      </p:sp>
+      <p:sp>
+        <p:nvSpPr>
+          <p:cNvPr id="8" name="h512 label"/>
+          <p:cNvSpPr txBox="1"/>
+          <p:nvPr/>
+        </p:nvSpPr>
+        <p:spPr>
+          <a:xfrm>
+            <a:off x="4617720" y="2606040"/>
+            <a:ext cx="2971800" cy="868680"/>
+          </a:xfrm>
+          <a:prstGeom prst="rect">
+            <a:avLst/>
+          </a:prstGeom>
+          <a:noFill/>
+          <a:ln/>
+        </p:spPr>
+        <p:txBody>
+          <a:bodyPr wrap="square" lIns="0" tIns="0" rIns="0" bIns="0" rtlCol="0" anchor="t"/>
+          <a:lstStyle/>
+          <a:p>
+            <a:pPr indent="0" marL="0">
+              <a:buNone/>
+            </a:pPr>
+            <a:r>
+              <a:rPr lang="en-US" sz="1600" b="1" dirty="0">
+                <a:solidFill>
+                  <a:schemeClr val="tx1"/>
+                </a:solidFill>
+              </a:rPr>
+              <a:t>512 agents</a:t>
+            </a:r>
+            <a:endParaRPr lang="en-US" sz="1600" dirty="0"/>
+          </a:p>
+          <a:p>
+            <a:pPr indent="0" marL="0">
+              <a:buNone/>
+            </a:pPr>
+            <a:r>
+              <a:rPr lang="en-US" sz="1300" dirty="0">
+                <a:solidFill>
+                  <a:schemeClr val="accent2"/>
+                </a:solidFill>
+              </a:rPr>
+              <a:t>598 s mean TTFT, 90% from cache</a:t>
+            </a:r>
+            <a:endParaRPr lang="en-US" sz="1600" dirty="0"/>
+          </a:p>
+        </p:txBody>
+      </p:sp>
+      <p:sp>
+        <p:nvSpPr>
+          <p:cNvPr id="9" name="ok card"/>
+          <p:cNvSpPr/>
+          <p:nvPr/>
+        </p:nvSpPr>
+        <p:spPr>
+          <a:xfrm>
+            <a:off x="8138160" y="1463040"/>
+            <a:ext cx="3520440" cy="2103120"/>
+          </a:xfrm>
+          <a:prstGeom prst="roundRect">
+            <a:avLst>
+              <a:gd name="adj" fmla="val 5217"/>
+            </a:avLst>
+          </a:prstGeom>
+          <a:solidFill>
+            <a:srgbClr val="EEF3F7"/>
+          </a:solidFill>
+          <a:ln w="12700">
+            <a:solidFill>
+              <a:srgbClr val="EEF3F7"/>
+            </a:solidFill>
+            <a:prstDash val="solid"/>
+          </a:ln>
+        </p:spPr>
+      </p:sp>
+      <p:sp>
+        <p:nvSpPr>
+          <p:cNvPr id="10" name="ok value"/>
+          <p:cNvSpPr txBox="1"/>
+          <p:nvPr/>
+        </p:nvSpPr>
+        <p:spPr>
+          <a:xfrm>
+            <a:off x="8412480" y="1691640"/>
+            <a:ext cx="2971800" cy="914400"/>
+          </a:xfrm>
+          <a:prstGeom prst="rect">
+            <a:avLst/>
+          </a:prstGeom>
+          <a:noFill/>
+          <a:ln/>
+        </p:spPr>
+        <p:txBody>
+          <a:bodyPr wrap="square" lIns="0" tIns="0" rIns="0" bIns="0" rtlCol="0" anchor="ctr"/>
+          <a:lstStyle/>
+          <a:p>
+            <a:pPr indent="0" marL="0">
+              <a:buNone/>
+            </a:pPr>
+            <a:r>
+              <a:rPr lang="en-US" sz="4800" b="1" dirty="0">
+                <a:solidFill>
+                  <a:schemeClr val="accent1"/>
+                </a:solidFill>
+                <a:latin typeface="Cambria" pitchFamily="34" charset="0"/>
+                <a:ea typeface="Cambria" pitchFamily="34" charset="-122"/>
+                <a:cs typeface="Cambria" pitchFamily="34" charset="-120"/>
+              </a:rPr>
+              <a:t>99.9%</a:t>
+            </a:r>
+            <a:endParaRPr lang="en-US" sz="4800" dirty="0"/>
+          </a:p>
+        </p:txBody>
+      </p:sp>
+      <p:sp>
+        <p:nvSpPr>
+          <p:cNvPr id="11" name="ok label"/>
+          <p:cNvSpPr txBox="1"/>
+          <p:nvPr/>
+        </p:nvSpPr>
+        <p:spPr>
+          <a:xfrm>
+            <a:off x="8412480" y="2606040"/>
+            <a:ext cx="2971800" cy="868680"/>
+          </a:xfrm>
+          <a:prstGeom prst="rect">
+            <a:avLst/>
+          </a:prstGeom>
+          <a:noFill/>
+          <a:ln/>
+        </p:spPr>
+        <p:txBody>
+          <a:bodyPr wrap="square" lIns="0" tIns="0" rIns="0" bIns="0" rtlCol="0" anchor="t"/>
+          <a:lstStyle/>
+          <a:p>
+            <a:pPr indent="0" marL="0">
+              <a:buNone/>
+            </a:pPr>
+            <a:r>
+              <a:rPr lang="en-US" sz="1600" b="1" dirty="0">
+                <a:solidFill>
+                  <a:schemeClr val="tx1"/>
+                </a:solidFill>
+              </a:rPr>
+              <a:t>requests completed</a:t>
+            </a:r>
+            <a:endParaRPr lang="en-US" sz="1600" dirty="0"/>
+          </a:p>
+          <a:p>
+            <a:pPr indent="0" marL="0">
+              <a:buNone/>
+            </a:pPr>
+            <a:r>
+              <a:rPr lang="en-US" sz="1300" dirty="0">
+                <a:solidFill>
+                  <a:schemeClr val="accent2"/>
+                </a:solidFill>
+              </a:rPr>
+              <a:t>12,789 of 12,800 at 512 agents; the rest exceeded the context</a:t>
+            </a:r>
+            <a:endParaRPr lang="en-US" sz="1600" dirty="0"/>
+          </a:p>
+        </p:txBody>
+      </p:sp>
+      <p:sp>
+        <p:nvSpPr>
+          <p:cNvPr id="12" name="heavy text"/>
+          <p:cNvSpPr txBox="1"/>
+          <p:nvPr/>
+        </p:nvSpPr>
+        <p:spPr>
+          <a:xfrm>
+            <a:off x="548640" y="3931920"/>
+            <a:ext cx="11064240" cy="1188720"/>
+          </a:xfrm>
+          <a:prstGeom prst="rect">
+            <a:avLst/>
+          </a:prstGeom>
+          <a:noFill/>
+          <a:ln/>
+        </p:spPr>
+        <p:txBody>
+          <a:bodyPr wrap="square" lIns="0" tIns="0" rIns="0" bIns="0" rtlCol="0" anchor="t"/>
+          <a:lstStyle/>
+          <a:p>
+            <a:pPr indent="0" marL="0">
+              <a:buNone/>
+            </a:pPr>
+            <a:r>
+              <a:rPr lang="en-US" sz="1500" dirty="0">
+                <a:solidFill>
+                  <a:schemeClr val="tx1"/>
+                </a:solidFill>
+              </a:rPr>
+              <a:t>25 rounds per agent session and up to 512 output tokens per round, the setting used in industry agentic offload studies: sessions grow to tens of thousands of tokens, far beyond what four GPUs hold. LifeboatCache served about 90% of every prompt from its DRAM and NVMe tiers at both loads.</a:t>
+            </a:r>
+            <a:endParaRPr lang="en-US" sz="1500" dirty="0"/>
+          </a:p>
+        </p:txBody>
+      </p:sp>
+      <p:sp>
+        <p:nvSpPr>
+          <p:cNvPr id="13" name="footnote"/>
+          <p:cNvSpPr txBox="1"/>
+          <p:nvPr/>
+        </p:nvSpPr>
+        <p:spPr>
+          <a:xfrm>
+            <a:off x="548640" y="5806440"/>
+            <a:ext cx="11064240" cy="502920"/>
+          </a:xfrm>
+          <a:prstGeom prst="rect">
+            <a:avLst/>
+          </a:prstGeom>
+          <a:noFill/>
+          <a:ln/>
+        </p:spPr>
+        <p:txBody>
+          <a:bodyPr wrap="square" lIns="0" tIns="0" rIns="0" bIns="0" rtlCol="0" anchor="t"/>
+          <a:lstStyle/>
+          <a:p>
+            <a:pPr indent="0" marL="0">
+              <a:buNone/>
+            </a:pPr>
+            <a:r>
+              <a:rPr lang="en-US" sz="1100" dirty="0">
+                <a:solidFill>
+                  <a:schemeClr val="accent2"/>
+                </a:solidFill>
+              </a:rPr>
+              <a:t>Qwen3-235B-A22B-FP8 on 4x RTX PRO 6000, vLLM 0.32, LifeboatCache 0.1.23 with 256 GB host DRAM and a 3 TB NVMe tier; 40,192-token context. Mean time to first token includes queueing: 256 to 512 agents share four GPUs.</a:t>
+            </a:r>
+            <a:endParaRPr lang="en-US" sz="1100" dirty="0"/>
+          </a:p>
+        </p:txBody>
+      </p:sp>
+      <p:sp>
+        <p:nvSpPr>
+          <p:cNvPr id="25" name="Slide Number Placeholder 0"/>
+          <p:cNvSpPr>
+            <a:spLocks noGrp="1"/>
+          </p:cNvSpPr>
+          <p:nvPr>
+            <p:ph type="sldNum" sz="quarter" idx="4294967295"/>
+          </p:nvPr>
+        </p:nvSpPr>
+        <p:spPr>
+          <a:xfrm>
+            <a:off x="11247120" y="6400800"/>
+            <a:ext cx="457200" cy="274320"/>
+          </a:xfrm>
+          <a:prstGeom prst="rect">
+            <a:avLst/>
+          </a:prstGeom>
+          <a:extLst>
+            <a:ext uri="{C572A759-6A51-4108-AA02-DFA0A04FC94B}">
+              <ma14:wrappingTextBoxFlag xmlns:ma14="http://schemas.microsoft.com/office/mac/drawingml/2011/main" val="0"/>
+            </a:ext>
+          </a:extLst>
+        </p:spPr>
+        <p:txBody>
+          <a:bodyPr/>
+          <a:lstStyle>
+            <a:lvl1pPr>
+              <a:defRPr sz="1000">
+                <a:solidFill>
+                  <a:srgbClr val="5B6C8F"/>
+                </a:solidFill>
+              </a:defRPr>
+            </a:lvl1pPr>
+          </a:lstStyle>
+          <a:p>
+            <a:pPr algn="l"/>
+            <a:fld id="{F7021451-1387-4CA6-816F-3879F97B5CBC}" type="slidenum">
+              <a:rPr b="0" lang="en-US"/>
+              <a:t>10</a:t>
+            </a:fld>
+            <a:endParaRPr lang="en-US"/>
+          </a:p>
+        </p:txBody>
+      </p:sp>
+    </p:spTree>
+  </p:cSld>
+  <p:clrMapOvr>
+    <a:masterClrMapping/>
+  </p:clrMapOvr>
+</p:sld>
+</file>
+
+<file path=ppt/slides/slide11.xml><?xml version="1.0" encoding="utf-8"?>
+<p:sld xmlns:a="http://schemas.openxmlformats.org/drawingml/2006/main" xmlns:r="http://schemas.openxmlformats.org/officeDocument/2006/relationships" xmlns:p="http://schemas.openxmlformats.org/presentationml/2006/main">
+  <p:cSld name="Slide 11">
+    <p:spTree>
+      <p:nvGrpSpPr>
+        <p:cNvPr id="1" name=""/>
+        <p:cNvGrpSpPr/>
+        <p:nvPr/>
+      </p:nvGrpSpPr>
+      <p:grpSpPr>
+        <a:xfrm>
+          <a:off x="0" y="0"/>
+          <a:ext cx="0" cy="0"/>
+          <a:chOff x="0" y="0"/>
+          <a:chExt cx="0" cy="0"/>
+        </a:xfrm>
+      </p:grpSpPr>
+      <p:sp>
+        <p:nvSpPr>
+          <p:cNvPr id="2" name="Text 0"/>
+          <p:cNvSpPr/>
+          <p:nvPr>
+            <p:ph idx="100" type="title" hasCustomPrompt="1"/>
+          </p:nvPr>
+        </p:nvSpPr>
+        <p:spPr>
+          <a:xfrm>
+            <a:off x="548640" y="365760"/>
+            <a:ext cx="11064240" cy="822960"/>
+          </a:xfrm>
+          <a:prstGeom prst="rect">
+            <a:avLst/>
+          </a:prstGeom>
+          <a:noFill/>
+          <a:ln/>
+        </p:spPr>
+        <p:txBody>
+          <a:bodyPr wrap="square" lIns="0" tIns="0" rIns="0" bIns="0" rtlCol="0" anchor="ctr"/>
+          <a:lstStyle/>
+          <a:p>
+            <a:pPr algn="l" indent="0" marL="0">
+              <a:buNone/>
+            </a:pPr>
+            <a:r>
+              <a:rPr lang="en-US" sz="3200" b="1" dirty="0">
+                <a:solidFill>
+                  <a:schemeClr val="tx2"/>
+                </a:solidFill>
+                <a:latin typeface="Cambria" pitchFamily="34" charset="0"/>
+                <a:ea typeface="Cambria" pitchFamily="34" charset="-122"/>
+                <a:cs typeface="Cambria" pitchFamily="34" charset="-120"/>
+              </a:rPr>
+              <a:t>Under sustained load, LifeboatCache keeps its cache hits</a:t>
+            </a:r>
+            <a:endParaRPr lang="en-US" sz="3200" dirty="0"/>
+          </a:p>
+        </p:txBody>
+      </p:sp>
+      <p:graphicFrame>
+        <p:nvGraphicFramePr>
+          <p:cNvPr id="3" name="timeline 2" descr=""/>
+          <p:cNvGraphicFramePr/>
+          <p:nvPr/>
+        </p:nvGraphicFramePr>
+        <p:xfrm>
+          <a:off x="548640" y="1325880"/>
+          <a:ext cx="5394960" cy="4206240"/>
+        </p:xfrm>
+        <a:graphic xmlns:a="http://schemas.openxmlformats.org/drawingml/2006/main">
+          <a:graphicData uri="http://schemas.openxmlformats.org/drawingml/2006/chart">
+            <c:chart xmlns:c="http://schemas.openxmlformats.org/drawingml/2006/chart" r:id="rId1"/>
+          </a:graphicData>
+        </a:graphic>
+      </p:graphicFrame>
+      <p:graphicFrame>
+        <p:nvGraphicFramePr>
+          <p:cNvPr id="4" name="timeline 1" descr=""/>
+          <p:cNvGraphicFramePr/>
+          <p:nvPr/>
+        </p:nvGraphicFramePr>
+        <p:xfrm>
+          <a:off x="6217920" y="1325880"/>
+          <a:ext cx="5394960" cy="4206240"/>
+        </p:xfrm>
+        <a:graphic xmlns:a="http://schemas.openxmlformats.org/drawingml/2006/main">
+          <a:graphicData uri="http://schemas.openxmlformats.org/drawingml/2006/chart">
+            <c:chart xmlns:c="http://schemas.openxmlformats.org/drawingml/2006/chart" r:id="rId2"/>
+          </a:graphicData>
+        </a:graphic>
+      </p:graphicFrame>
+      <p:sp>
+        <p:nvSpPr>
+          <p:cNvPr id="5" name="footnote"/>
+          <p:cNvSpPr txBox="1"/>
+          <p:nvPr/>
+        </p:nvSpPr>
+        <p:spPr>
+          <a:xfrm>
+            <a:off x="548640" y="5806440"/>
+            <a:ext cx="11064240" cy="502920"/>
+          </a:xfrm>
+          <a:prstGeom prst="rect">
+            <a:avLst/>
+          </a:prstGeom>
+          <a:noFill/>
+          <a:ln/>
+        </p:spPr>
+        <p:txBody>
+          <a:bodyPr wrap="square" lIns="0" tIns="0" rIns="0" bIns="0" rtlCol="0" anchor="t"/>
+          <a:lstStyle/>
+          <a:p>
+            <a:pPr indent="0" marL="0">
+              <a:buNone/>
+            </a:pPr>
+            <a:r>
+              <a:rPr lang="en-US" sz="1100" dirty="0">
+                <a:solidFill>
+                  <a:schemeClr val="accent2"/>
+                </a:solidFill>
+              </a:rPr>
+              <a:t>256 agents, same server and settings. LMCache 0.5.6 with 512 GB DRAM + NVMe evicted entries from its DRAM tier while they were being loaded (1,761 missing-key events in 90 minutes); its share of cached prompt tokens fell from 91% to 47% and the run did not complete. LifeboatCache stayed at 91–94% to the end.</a:t>
+            </a:r>
+            <a:endParaRPr lang="en-US" sz="1100" dirty="0"/>
+          </a:p>
+        </p:txBody>
+      </p:sp>
+      <p:sp>
+        <p:nvSpPr>
+          <p:cNvPr id="25" name="Slide Number Placeholder 0"/>
+          <p:cNvSpPr>
+            <a:spLocks noGrp="1"/>
+          </p:cNvSpPr>
+          <p:nvPr>
+            <p:ph type="sldNum" sz="quarter" idx="4294967295"/>
+          </p:nvPr>
+        </p:nvSpPr>
+        <p:spPr>
+          <a:xfrm>
+            <a:off x="11247120" y="6400800"/>
+            <a:ext cx="457200" cy="274320"/>
+          </a:xfrm>
+          <a:prstGeom prst="rect">
+            <a:avLst/>
+          </a:prstGeom>
+          <a:extLst>
+            <a:ext uri="{C572A759-6A51-4108-AA02-DFA0A04FC94B}">
+              <ma14:wrappingTextBoxFlag xmlns:ma14="http://schemas.microsoft.com/office/mac/drawingml/2011/main" val="0"/>
+            </a:ext>
+          </a:extLst>
+        </p:spPr>
+        <p:txBody>
+          <a:bodyPr/>
+          <a:lstStyle>
+            <a:lvl1pPr>
+              <a:defRPr sz="1000">
+                <a:solidFill>
+                  <a:srgbClr val="5B6C8F"/>
+                </a:solidFill>
+              </a:defRPr>
+            </a:lvl1pPr>
+          </a:lstStyle>
+          <a:p>
+            <a:pPr algn="l"/>
+            <a:fld id="{F7021451-1387-4CA6-816F-3879F97B5CBC}" type="slidenum">
+              <a:rPr b="0" lang="en-US"/>
+              <a:t>11</a:t>
+            </a:fld>
+            <a:endParaRPr lang="en-US"/>
+          </a:p>
+        </p:txBody>
+      </p:sp>
+    </p:spTree>
+  </p:cSld>
+  <p:clrMapOvr>
+    <a:masterClrMapping/>
+  </p:clrMapOvr>
+</p:sld>
+</file>
+
+<file path=ppt/slides/slide12.xml><?xml version="1.0" encoding="utf-8"?>
+<p:sld xmlns:a="http://schemas.openxmlformats.org/drawingml/2006/main" xmlns:r="http://schemas.openxmlformats.org/officeDocument/2006/relationships" xmlns:p="http://schemas.openxmlformats.org/presentationml/2006/main">
+  <p:cSld name="Slide 12">
+    <p:spTree>
+      <p:nvGrpSpPr>
+        <p:cNvPr id="1" name=""/>
+        <p:cNvGrpSpPr/>
+        <p:nvPr/>
+      </p:nvGrpSpPr>
+      <p:grpSpPr>
+        <a:xfrm>
+          <a:off x="0" y="0"/>
+          <a:ext cx="0" cy="0"/>
+          <a:chOff x="0" y="0"/>
+          <a:chExt cx="0" cy="0"/>
+        </a:xfrm>
+      </p:grpSpPr>
+      <p:sp>
+        <p:nvSpPr>
+          <p:cNvPr id="2" name="Text 0"/>
+          <p:cNvSpPr/>
+          <p:nvPr>
+            <p:ph idx="100" type="title" hasCustomPrompt="1"/>
+          </p:nvPr>
+        </p:nvSpPr>
+        <p:spPr>
+          <a:xfrm>
+            <a:off x="548640" y="365760"/>
+            <a:ext cx="11064240" cy="822960"/>
+          </a:xfrm>
+          <a:prstGeom prst="rect">
+            <a:avLst/>
+          </a:prstGeom>
+          <a:noFill/>
+          <a:ln/>
+        </p:spPr>
+        <p:txBody>
+          <a:bodyPr wrap="square" lIns="0" tIns="0" rIns="0" bIns="0" rtlCol="0" anchor="ctr"/>
+          <a:lstStyle/>
+          <a:p>
+            <a:pPr algn="l" indent="0" marL="0">
+              <a:buNone/>
+            </a:pPr>
+            <a:r>
+              <a:rPr lang="en-US" sz="3200" b="1" dirty="0">
+                <a:solidFill>
+                  <a:schemeClr val="tx2"/>
+                </a:solidFill>
+                <a:latin typeface="Cambria" pitchFamily="34" charset="0"/>
+                <a:ea typeface="Cambria" pitchFamily="34" charset="-122"/>
+                <a:cs typeface="Cambria" pitchFamily="34" charset="-120"/>
+              </a:rPr>
+              <a:t>More DRAM, more throughput: +12% from 64 to 256 GB</a:t>
+            </a:r>
+            <a:endParaRPr lang="en-US" sz="3200" dirty="0"/>
+          </a:p>
+        </p:txBody>
+      </p:sp>
+      <p:graphicFrame>
+        <p:nvGraphicFramePr>
+          <p:cNvPr id="3" name="heavy dram tps" descr=""/>
+          <p:cNvGraphicFramePr/>
+          <p:nvPr/>
+        </p:nvGraphicFramePr>
+        <p:xfrm>
+          <a:off x="548640" y="1371600"/>
+          <a:ext cx="5394960" cy="4206240"/>
+        </p:xfrm>
+        <a:graphic xmlns:a="http://schemas.openxmlformats.org/drawingml/2006/main">
+          <a:graphicData uri="http://schemas.openxmlformats.org/drawingml/2006/chart">
+            <c:chart xmlns:c="http://schemas.openxmlformats.org/drawingml/2006/chart" r:id="rId1"/>
+          </a:graphicData>
+        </a:graphic>
+      </p:graphicFrame>
+      <p:graphicFrame>
+        <p:nvGraphicFramePr>
+          <p:cNvPr id="4" name="heavy dram ttft" descr=""/>
+          <p:cNvGraphicFramePr/>
+          <p:nvPr/>
+        </p:nvGraphicFramePr>
+        <p:xfrm>
+          <a:off x="6217920" y="1371600"/>
+          <a:ext cx="5394960" cy="4206240"/>
+        </p:xfrm>
+        <a:graphic xmlns:a="http://schemas.openxmlformats.org/drawingml/2006/main">
+          <a:graphicData uri="http://schemas.openxmlformats.org/drawingml/2006/chart">
+            <c:chart xmlns:c="http://schemas.openxmlformats.org/drawingml/2006/chart" r:id="rId2"/>
+          </a:graphicData>
+        </a:graphic>
+      </p:graphicFrame>
+      <p:sp>
+        <p:nvSpPr>
+          <p:cNvPr id="5" name="footnote"/>
+          <p:cNvSpPr txBox="1"/>
+          <p:nvPr/>
+        </p:nvSpPr>
+        <p:spPr>
+          <a:xfrm>
+            <a:off x="548640" y="5806440"/>
+            <a:ext cx="11064240" cy="502920"/>
+          </a:xfrm>
+          <a:prstGeom prst="rect">
+            <a:avLst/>
+          </a:prstGeom>
+          <a:noFill/>
+          <a:ln/>
+        </p:spPr>
+        <p:txBody>
+          <a:bodyPr wrap="square" lIns="0" tIns="0" rIns="0" bIns="0" rtlCol="0" anchor="t"/>
+          <a:lstStyle/>
+          <a:p>
+            <a:pPr indent="0" marL="0">
+              <a:buNone/>
+            </a:pPr>
+            <a:r>
+              <a:rPr lang="en-US" sz="1100" dirty="0">
+                <a:solidFill>
+                  <a:schemeClr val="accent2"/>
+                </a:solidFill>
+              </a:rPr>
+              <a:t>LifeboatCache with its NVMe tier in both runs; DRAM is the host-RAM tier for the whole server. Share of prompt tokens from cache 85% at 64 GB, 89% at 256 GB.</a:t>
+            </a:r>
+            <a:endParaRPr lang="en-US" sz="1100" dirty="0"/>
+          </a:p>
+        </p:txBody>
+      </p:sp>
+      <p:sp>
+        <p:nvSpPr>
+          <p:cNvPr id="25" name="Slide Number Placeholder 0"/>
+          <p:cNvSpPr>
+            <a:spLocks noGrp="1"/>
+          </p:cNvSpPr>
+          <p:nvPr>
+            <p:ph type="sldNum" sz="quarter" idx="4294967295"/>
+          </p:nvPr>
+        </p:nvSpPr>
+        <p:spPr>
+          <a:xfrm>
+            <a:off x="11247120" y="6400800"/>
+            <a:ext cx="457200" cy="274320"/>
+          </a:xfrm>
+          <a:prstGeom prst="rect">
+            <a:avLst/>
+          </a:prstGeom>
+          <a:extLst>
+            <a:ext uri="{C572A759-6A51-4108-AA02-DFA0A04FC94B}">
+              <ma14:wrappingTextBoxFlag xmlns:ma14="http://schemas.microsoft.com/office/mac/drawingml/2011/main" val="0"/>
+            </a:ext>
+          </a:extLst>
+        </p:spPr>
+        <p:txBody>
+          <a:bodyPr/>
+          <a:lstStyle>
+            <a:lvl1pPr>
+              <a:defRPr sz="1000">
+                <a:solidFill>
+                  <a:srgbClr val="5B6C8F"/>
+                </a:solidFill>
+              </a:defRPr>
+            </a:lvl1pPr>
+          </a:lstStyle>
+          <a:p>
+            <a:pPr algn="l"/>
+            <a:fld id="{F7021451-1387-4CA6-816F-3879F97B5CBC}" type="slidenum">
+              <a:rPr b="0" lang="en-US"/>
+              <a:t>12</a:t>
+            </a:fld>
+            <a:endParaRPr lang="en-US"/>
+          </a:p>
+        </p:txBody>
+      </p:sp>
+    </p:spTree>
+  </p:cSld>
+  <p:clrMapOvr>
+    <a:masterClrMapping/>
+  </p:clrMapOvr>
+</p:sld>
+</file>
+
+<file path=ppt/slides/slide13.xml><?xml version="1.0" encoding="utf-8"?>
+<p:sld xmlns:a="http://schemas.openxmlformats.org/drawingml/2006/main" xmlns:r="http://schemas.openxmlformats.org/officeDocument/2006/relationships" xmlns:p="http://schemas.openxmlformats.org/presentationml/2006/main">
+  <p:cSld name="Slide 13">
+    <p:spTree>
+      <p:nvGrpSpPr>
+        <p:cNvPr id="1" name=""/>
+        <p:cNvGrpSpPr/>
+        <p:nvPr/>
+      </p:nvGrpSpPr>
+      <p:grpSpPr>
+        <a:xfrm>
+          <a:off x="0" y="0"/>
+          <a:ext cx="0" cy="0"/>
+          <a:chOff x="0" y="0"/>
+          <a:chExt cx="0" cy="0"/>
+        </a:xfrm>
+      </p:grpSpPr>
+      <p:sp>
+        <p:nvSpPr>
+          <p:cNvPr id="2" name="Text 0"/>
+          <p:cNvSpPr/>
+          <p:nvPr>
+            <p:ph idx="100" type="title" hasCustomPrompt="1"/>
+          </p:nvPr>
+        </p:nvSpPr>
+        <p:spPr>
+          <a:xfrm>
+            <a:off x="548640" y="365760"/>
+            <a:ext cx="11064240" cy="822960"/>
+          </a:xfrm>
+          <a:prstGeom prst="rect">
+            <a:avLst/>
+          </a:prstGeom>
+          <a:noFill/>
+          <a:ln/>
+        </p:spPr>
+        <p:txBody>
+          <a:bodyPr wrap="square" lIns="0" tIns="0" rIns="0" bIns="0" rtlCol="0" anchor="ctr"/>
+          <a:lstStyle/>
+          <a:p>
+            <a:pPr algn="l" indent="0" marL="0">
+              <a:buNone/>
+            </a:pPr>
+            <a:r>
+              <a:rPr lang="en-US" sz="3200" b="1" dirty="0">
+                <a:solidFill>
+                  <a:schemeClr val="tx2"/>
+                </a:solidFill>
+                <a:latin typeface="Cambria" pitchFamily="34" charset="0"/>
+                <a:ea typeface="Cambria" pitchFamily="34" charset="-122"/>
+                <a:cs typeface="Cambria" pitchFamily="34" charset="-120"/>
+              </a:rPr>
               <a:t>32 agents: no overhead when the GPUs hold the sessions</a:t>
             </a:r>
             <a:endParaRPr lang="en-US" sz="3200" dirty="0"/>
@@ -5703,7 +8708,7 @@
             <a:pPr algn="l"/>
             <a:fld id="{F7021451-1387-4CA6-816F-3879F97B5CBC}" type="slidenum">
               <a:rPr b="0" lang="en-US"/>
-              <a:t>10</a:t>
+              <a:t>13</a:t>
             </a:fld>
             <a:endParaRPr lang="en-US"/>
           </a:p>
@@ -5717,9 +8722,9 @@
 </p:sld>
 </file>
 
-<file path=ppt/slides/slide11.xml><?xml version="1.0" encoding="utf-8"?>
+<file path=ppt/slides/slide14.xml><?xml version="1.0" encoding="utf-8"?>
 <p:sld xmlns:a="http://schemas.openxmlformats.org/drawingml/2006/main" xmlns:r="http://schemas.openxmlformats.org/officeDocument/2006/relationships" xmlns:p="http://schemas.openxmlformats.org/presentationml/2006/main">
-  <p:cSld name="Slide 11">
+  <p:cSld name="Slide 14">
     <p:spTree>
       <p:nvGrpSpPr>
         <p:cNvPr id="1" name=""/>
@@ -5777,7 +8782,7 @@
       </p:sp>
       <p:graphicFrame>
         <p:nvGraphicFramePr>
-          <p:cNvPr id="12" name="scale table"/>
+          <p:cNvPr id="15" name="scale table"/>
           <p:cNvGraphicFramePr>
             <a:graphicFrameLocks noGrp="1"/>
           </p:cNvGraphicFramePr>
@@ -6921,7 +9926,7 @@
             <a:pPr algn="l"/>
             <a:fld id="{F7021451-1387-4CA6-816F-3879F97B5CBC}" type="slidenum">
               <a:rPr b="0" lang="en-US"/>
-              <a:t>11</a:t>
+              <a:t>14</a:t>
             </a:fld>
             <a:endParaRPr lang="en-US"/>
           </a:p>
@@ -6935,9 +9940,9 @@
 </p:sld>
 </file>
 
-<file path=ppt/slides/slide12.xml><?xml version="1.0" encoding="utf-8"?>
+<file path=ppt/slides/slide15.xml><?xml version="1.0" encoding="utf-8"?>
 <p:sld xmlns:a="http://schemas.openxmlformats.org/drawingml/2006/main" xmlns:r="http://schemas.openxmlformats.org/officeDocument/2006/relationships" xmlns:p="http://schemas.openxmlformats.org/presentationml/2006/main">
-  <p:cSld name="Slide 12">
+  <p:cSld name="Slide 15">
     <p:spTree>
       <p:nvGrpSpPr>
         <p:cNvPr id="1" name=""/>
@@ -6995,7 +10000,7 @@
       </p:sp>
       <p:graphicFrame>
         <p:nvGraphicFramePr>
-          <p:cNvPr id="13" name="repeat table"/>
+          <p:cNvPr id="16" name="repeat table"/>
           <p:cNvGraphicFramePr>
             <a:graphicFrameLocks noGrp="1"/>
           </p:cNvGraphicFramePr>
@@ -7699,7 +10704,7 @@
             <a:pPr algn="l"/>
             <a:fld id="{F7021451-1387-4CA6-816F-3879F97B5CBC}" type="slidenum">
               <a:rPr b="0" lang="en-US"/>
-              <a:t>12</a:t>
+              <a:t>15</a:t>
             </a:fld>
             <a:endParaRPr lang="en-US"/>
           </a:p>
@@ -7713,9 +10718,9 @@
 </p:sld>
 </file>
 
-<file path=ppt/slides/slide13.xml><?xml version="1.0" encoding="utf-8"?>
+<file path=ppt/slides/slide16.xml><?xml version="1.0" encoding="utf-8"?>
 <p:sld xmlns:a="http://schemas.openxmlformats.org/drawingml/2006/main" xmlns:r="http://schemas.openxmlformats.org/officeDocument/2006/relationships" xmlns:p="http://schemas.openxmlformats.org/presentationml/2006/main">
-  <p:cSld name="Slide 13">
+  <p:cSld name="Slide 16">
     <p:spTree>
       <p:nvGrpSpPr>
         <p:cNvPr id="1" name=""/>

</xml_diff>

<commit_message>
gpt-oss-20b on one RTX PRO 6000: vLLM alone vs LMCache vs LifeboatCache
Co-Authored-By: Claude Opus 5.5 <noreply@anthropic.com>
</commit_message>
<xml_diff>
--- a/reports/agentic-4x-rtxpro6000-qwen3-235b-a22b/LifeboatCache_vLLM_Agentic_4xRTXPRO6000.pptx
+++ b/reports/agentic-4x-rtxpro6000-qwen3-235b-a22b/LifeboatCache_vLLM_Agentic_4xRTXPRO6000.pptx
@@ -21,9 +21,10 @@
     <p:sldId id="269" r:id="rId15"/>
     <p:sldId id="270" r:id="rId16"/>
     <p:sldId id="271" r:id="rId17"/>
+    <p:sldId id="272" r:id="rId18"/>
   </p:sldIdLst>
   <p:notesMasterIdLst>
-    <p:notesMasterId r:id="rId18"/>
+    <p:notesMasterId r:id="rId19"/>
   </p:notesMasterIdLst>
   <p:sldSz cx="12192000" cy="6858000"/>
   <p:notesSz cx="6858000" cy="12192000"/>
@@ -1514,6 +1515,612 @@
           <c:showLeaderLines val="0"/>
         </c:dLbls>
         <c:gapWidth val="60"/>
+        <c:overlap val="0"/>
+        <c:axId val="2094734554"/>
+        <c:axId val="2094734552"/>
+        <c:axId val="2094734556"/>
+      </c:barChart>
+      <c:catAx>
+        <c:axId val="2094734554"/>
+        <c:scaling>
+          <c:orientation val="minMax"/>
+        </c:scaling>
+        <c:delete val="0"/>
+        <c:axPos val="b"/>
+        <c:numFmt formatCode="General" sourceLinked="1"/>
+        <c:majorTickMark val="out"/>
+        <c:minorTickMark val="none"/>
+        <c:tickLblPos val="low"/>
+        <c:spPr>
+          <a:ln w="12700" cap="flat">
+            <a:solidFill>
+              <a:srgbClr val="888888"/>
+            </a:solidFill>
+            <a:prstDash val="solid"/>
+            <a:round/>
+          </a:ln>
+        </c:spPr>
+        <c:txPr>
+          <a:bodyPr/>
+          <a:lstStyle/>
+          <a:p>
+            <a:pPr>
+              <a:defRPr sz="1200" b="0" i="0" u="none" strike="noStrike">
+                <a:solidFill>
+                  <a:srgbClr val="1B2430"/>
+                </a:solidFill>
+                <a:latin typeface="+mn-lt"/>
+              </a:defRPr>
+            </a:pPr>
+            <a:endParaRPr lang="en-US"/>
+          </a:p>
+        </c:txPr>
+        <c:crossAx val="2094734552"/>
+        <c:crosses val="autoZero"/>
+        <c:auto val="1"/>
+        <c:lblAlgn val="ctr"/>
+        <c:noMultiLvlLbl val="1"/>
+      </c:catAx>
+      <c:valAx>
+        <c:axId val="2094734552"/>
+        <c:scaling>
+          <c:orientation val="minMax"/>
+          <c:min val="0"/>
+        </c:scaling>
+        <c:delete val="0"/>
+        <c:axPos val="l"/>
+        <c:majorGridlines>
+          <c:spPr>
+            <a:ln w="9525" cap="flat">
+              <a:solidFill>
+                <a:srgbClr val="D9E0E7"/>
+              </a:solidFill>
+              <a:prstDash val="solid"/>
+              <a:round/>
+            </a:ln>
+          </c:spPr>
+        </c:majorGridlines>
+        <c:numFmt formatCode="General" sourceLinked="0"/>
+        <c:majorTickMark val="out"/>
+        <c:minorTickMark val="none"/>
+        <c:tickLblPos val="nextTo"/>
+        <c:spPr>
+          <a:ln w="12700" cap="flat">
+            <a:solidFill>
+              <a:srgbClr val="888888"/>
+            </a:solidFill>
+            <a:prstDash val="solid"/>
+            <a:round/>
+          </a:ln>
+        </c:spPr>
+        <c:txPr>
+          <a:bodyPr/>
+          <a:lstStyle/>
+          <a:p>
+            <a:pPr>
+              <a:defRPr sz="1100" b="0" i="0" u="none" strike="noStrike">
+                <a:solidFill>
+                  <a:srgbClr val="5B6C8F"/>
+                </a:solidFill>
+                <a:latin typeface="+mn-lt"/>
+              </a:defRPr>
+            </a:pPr>
+            <a:endParaRPr lang="en-US"/>
+          </a:p>
+        </c:txPr>
+        <c:crossAx val="2094734554"/>
+        <c:crosses val="autoZero"/>
+        <c:crossBetween val="between"/>
+      </c:valAx>
+      <c:spPr>
+        <a:noFill/>
+        <a:ln>
+          <a:noFill/>
+        </a:ln>
+        <a:effectLst/>
+      </c:spPr>
+    </c:plotArea>
+    <c:plotVisOnly val="1"/>
+    <c:dispBlanksAs val="span"/>
+  </c:chart>
+  <c:spPr>
+    <a:noFill/>
+    <a:ln>
+      <a:noFill/>
+    </a:ln>
+    <a:effectLst/>
+  </c:spPr>
+  <c:externalData r:id="rId1">
+    <c:autoUpdate val="0"/>
+  </c:externalData>
+</c:chartSpace>
+</file>
+
+<file path=ppt/charts/chart13.xml><?xml version="1.0" encoding="utf-8"?>
+<c:chartSpace xmlns:c="http://schemas.openxmlformats.org/drawingml/2006/chart" xmlns:a="http://schemas.openxmlformats.org/drawingml/2006/main" xmlns:r="http://schemas.openxmlformats.org/officeDocument/2006/relationships">
+  <c:date1904 val="0"/>
+  <c:roundedCorners val="1"/>
+  <c:chart>
+    <c:title>
+      <c:tx>
+        <c:rich>
+          <a:bodyPr/>
+          <a:lstStyle/>
+          <a:p>
+            <a:pPr>
+              <a:defRPr sz="1400" b="0" i="0" u="none" strike="noStrike">
+                <a:solidFill>
+                  <a:srgbClr val="1B2430"/>
+                </a:solidFill>
+                <a:latin typeface="+mn-lt"/>
+              </a:defRPr>
+            </a:pPr>
+            <a:r>
+              <a:rPr sz="1400" b="0" i="0" u="none" strike="noStrike">
+                <a:solidFill>
+                  <a:srgbClr val="1B2430"/>
+                </a:solidFill>
+                <a:latin typeface="+mn-lt"/>
+              </a:rPr>
+              <a:t>Output tokens/s, higher is better</a:t>
+            </a:r>
+          </a:p>
+        </c:rich>
+      </c:tx>
+      <c:layout/>
+      <c:overlay val="0"/>
+    </c:title>
+    <c:autoTitleDeleted val="0"/>
+    <c:plotArea>
+      <c:layout/>
+      <c:barChart>
+        <c:barDir val="col"/>
+        <c:grouping val="clustered"/>
+        <c:varyColors val="0"/>
+        <c:ser>
+          <c:idx val="0"/>
+          <c:order val="0"/>
+          <c:tx>
+            <c:strRef>
+              <c:f>Sheet1!$B$1</c:f>
+              <c:strCache>
+                <c:ptCount val="1"/>
+                <c:pt idx="0">
+                  <c:v>Output tok/s</c:v>
+                </c:pt>
+              </c:strCache>
+            </c:strRef>
+          </c:tx>
+          <c:spPr>
+            <a:solidFill>
+              <a:srgbClr val="A3AEBD"/>
+            </a:solidFill>
+            <a:effectLst/>
+          </c:spPr>
+          <c:invertIfNegative val="0"/>
+          <c:dLbls>
+            <c:numFmt formatCode="#,##0" sourceLinked="0"/>
+            <c:txPr>
+              <a:bodyPr/>
+              <a:lstStyle/>
+              <a:p>
+                <a:pPr>
+                  <a:defRPr b="0" i="0" strike="noStrike" sz="1200" u="none">
+                    <a:solidFill>
+                      <a:srgbClr val="1B2430"/>
+                    </a:solidFill>
+                    <a:latin typeface="+mn-lt"/>
+                  </a:defRPr>
+                </a:pPr>
+              </a:p>
+            </c:txPr>
+            <c:showLegendKey val="0"/>
+            <c:showVal val="1"/>
+            <c:showCatName val="0"/>
+            <c:showSerName val="0"/>
+            <c:showPercent val="0"/>
+            <c:showBubbleSize val="0"/>
+            <c:showLeaderLines val="0"/>
+          </c:dLbls>
+          <c:dPt>
+            <c:idx val="0"/>
+            <c:invertIfNegative val="0"/>
+            <c:bubble3D val="0"/>
+            <c:spPr>
+              <a:solidFill>
+                <a:srgbClr val="A3AEBD"/>
+              </a:solidFill>
+              <a:effectLst/>
+            </c:spPr>
+          </c:dPt>
+          <c:dPt>
+            <c:idx val="1"/>
+            <c:invertIfNegative val="0"/>
+            <c:bubble3D val="0"/>
+            <c:spPr>
+              <a:solidFill>
+                <a:srgbClr val="5B6C8F"/>
+              </a:solidFill>
+              <a:effectLst/>
+            </c:spPr>
+          </c:dPt>
+          <c:dPt>
+            <c:idx val="2"/>
+            <c:invertIfNegative val="0"/>
+            <c:bubble3D val="0"/>
+            <c:spPr>
+              <a:solidFill>
+                <a:srgbClr val="0E9F8E"/>
+              </a:solidFill>
+              <a:effectLst/>
+            </c:spPr>
+          </c:dPt>
+          <c:cat>
+            <c:multiLvlStrRef>
+              <c:f>Sheet1!$A$2:$A$4</c:f>
+              <c:multiLvlStrCache>
+                <c:ptCount val="3"/>
+                <c:lvl>
+                  <c:pt idx="0">
+                    <c:v>vLLM alone</c:v>
+                  </c:pt>
+                  <c:pt idx="1">
+                    <c:v>+ LMCache</c:v>
+                  </c:pt>
+                  <c:pt idx="2">
+                    <c:v>+ LifeboatCache</c:v>
+                  </c:pt>
+                </c:lvl>
+              </c:multiLvlStrCache>
+            </c:multiLvlStrRef>
+          </c:cat>
+          <c:val>
+            <c:numRef>
+              <c:f>Sheet1!$B$2:$B$4</c:f>
+              <c:numCache>
+                <c:formatCode>General</c:formatCode>
+                <c:ptCount val="3"/>
+                <c:pt idx="0">
+                  <c:v>1117</c:v>
+                </c:pt>
+                <c:pt idx="1">
+                  <c:v>1144</c:v>
+                </c:pt>
+                <c:pt idx="2">
+                  <c:v>1425</c:v>
+                </c:pt>
+              </c:numCache>
+            </c:numRef>
+          </c:val>
+        </c:ser>
+        <c:dLbls>
+          <c:numFmt formatCode="#,##0" sourceLinked="0"/>
+          <c:txPr>
+            <a:bodyPr/>
+            <a:lstStyle/>
+            <a:p>
+              <a:pPr>
+                <a:defRPr b="0" i="0" strike="noStrike" sz="1200" u="none">
+                  <a:solidFill>
+                    <a:srgbClr val="1B2430"/>
+                  </a:solidFill>
+                  <a:latin typeface="+mn-lt"/>
+                </a:defRPr>
+              </a:pPr>
+            </a:p>
+          </c:txPr>
+          <c:showLegendKey val="0"/>
+          <c:showVal val="1"/>
+          <c:showCatName val="0"/>
+          <c:showSerName val="0"/>
+          <c:showPercent val="0"/>
+          <c:showBubbleSize val="0"/>
+          <c:showLeaderLines val="0"/>
+        </c:dLbls>
+        <c:gapWidth val="50"/>
+        <c:overlap val="0"/>
+        <c:axId val="2094734554"/>
+        <c:axId val="2094734552"/>
+        <c:axId val="2094734556"/>
+      </c:barChart>
+      <c:catAx>
+        <c:axId val="2094734554"/>
+        <c:scaling>
+          <c:orientation val="minMax"/>
+        </c:scaling>
+        <c:delete val="0"/>
+        <c:axPos val="b"/>
+        <c:numFmt formatCode="General" sourceLinked="1"/>
+        <c:majorTickMark val="out"/>
+        <c:minorTickMark val="none"/>
+        <c:tickLblPos val="low"/>
+        <c:spPr>
+          <a:ln w="12700" cap="flat">
+            <a:solidFill>
+              <a:srgbClr val="888888"/>
+            </a:solidFill>
+            <a:prstDash val="solid"/>
+            <a:round/>
+          </a:ln>
+        </c:spPr>
+        <c:txPr>
+          <a:bodyPr/>
+          <a:lstStyle/>
+          <a:p>
+            <a:pPr>
+              <a:defRPr sz="1200" b="0" i="0" u="none" strike="noStrike">
+                <a:solidFill>
+                  <a:srgbClr val="1B2430"/>
+                </a:solidFill>
+                <a:latin typeface="+mn-lt"/>
+              </a:defRPr>
+            </a:pPr>
+            <a:endParaRPr lang="en-US"/>
+          </a:p>
+        </c:txPr>
+        <c:crossAx val="2094734552"/>
+        <c:crosses val="autoZero"/>
+        <c:auto val="1"/>
+        <c:lblAlgn val="ctr"/>
+        <c:noMultiLvlLbl val="1"/>
+      </c:catAx>
+      <c:valAx>
+        <c:axId val="2094734552"/>
+        <c:scaling>
+          <c:orientation val="minMax"/>
+          <c:min val="0"/>
+        </c:scaling>
+        <c:delete val="0"/>
+        <c:axPos val="l"/>
+        <c:majorGridlines>
+          <c:spPr>
+            <a:ln w="9525" cap="flat">
+              <a:solidFill>
+                <a:srgbClr val="D9E0E7"/>
+              </a:solidFill>
+              <a:prstDash val="solid"/>
+              <a:round/>
+            </a:ln>
+          </c:spPr>
+        </c:majorGridlines>
+        <c:numFmt formatCode="General" sourceLinked="0"/>
+        <c:majorTickMark val="out"/>
+        <c:minorTickMark val="none"/>
+        <c:tickLblPos val="nextTo"/>
+        <c:spPr>
+          <a:ln w="12700" cap="flat">
+            <a:solidFill>
+              <a:srgbClr val="888888"/>
+            </a:solidFill>
+            <a:prstDash val="solid"/>
+            <a:round/>
+          </a:ln>
+        </c:spPr>
+        <c:txPr>
+          <a:bodyPr/>
+          <a:lstStyle/>
+          <a:p>
+            <a:pPr>
+              <a:defRPr sz="1100" b="0" i="0" u="none" strike="noStrike">
+                <a:solidFill>
+                  <a:srgbClr val="5B6C8F"/>
+                </a:solidFill>
+                <a:latin typeface="+mn-lt"/>
+              </a:defRPr>
+            </a:pPr>
+            <a:endParaRPr lang="en-US"/>
+          </a:p>
+        </c:txPr>
+        <c:crossAx val="2094734554"/>
+        <c:crosses val="autoZero"/>
+        <c:crossBetween val="between"/>
+      </c:valAx>
+      <c:spPr>
+        <a:noFill/>
+        <a:ln>
+          <a:noFill/>
+        </a:ln>
+        <a:effectLst/>
+      </c:spPr>
+    </c:plotArea>
+    <c:plotVisOnly val="1"/>
+    <c:dispBlanksAs val="span"/>
+  </c:chart>
+  <c:spPr>
+    <a:noFill/>
+    <a:ln>
+      <a:noFill/>
+    </a:ln>
+    <a:effectLst/>
+  </c:spPr>
+  <c:externalData r:id="rId1">
+    <c:autoUpdate val="0"/>
+  </c:externalData>
+</c:chartSpace>
+</file>
+
+<file path=ppt/charts/chart14.xml><?xml version="1.0" encoding="utf-8"?>
+<c:chartSpace xmlns:c="http://schemas.openxmlformats.org/drawingml/2006/chart" xmlns:a="http://schemas.openxmlformats.org/drawingml/2006/main" xmlns:r="http://schemas.openxmlformats.org/officeDocument/2006/relationships">
+  <c:date1904 val="0"/>
+  <c:roundedCorners val="1"/>
+  <c:chart>
+    <c:title>
+      <c:tx>
+        <c:rich>
+          <a:bodyPr/>
+          <a:lstStyle/>
+          <a:p>
+            <a:pPr>
+              <a:defRPr sz="1400" b="0" i="0" u="none" strike="noStrike">
+                <a:solidFill>
+                  <a:srgbClr val="1B2430"/>
+                </a:solidFill>
+                <a:latin typeface="+mn-lt"/>
+              </a:defRPr>
+            </a:pPr>
+            <a:r>
+              <a:rPr sz="1400" b="0" i="0" u="none" strike="noStrike">
+                <a:solidFill>
+                  <a:srgbClr val="1B2430"/>
+                </a:solidFill>
+                <a:latin typeface="+mn-lt"/>
+              </a:rPr>
+              <a:t>Output tokens per joule (GPU), higher is better</a:t>
+            </a:r>
+          </a:p>
+        </c:rich>
+      </c:tx>
+      <c:layout/>
+      <c:overlay val="0"/>
+    </c:title>
+    <c:autoTitleDeleted val="0"/>
+    <c:plotArea>
+      <c:layout/>
+      <c:barChart>
+        <c:barDir val="col"/>
+        <c:grouping val="clustered"/>
+        <c:varyColors val="0"/>
+        <c:ser>
+          <c:idx val="0"/>
+          <c:order val="0"/>
+          <c:tx>
+            <c:strRef>
+              <c:f>Sheet1!$B$1</c:f>
+              <c:strCache>
+                <c:ptCount val="1"/>
+                <c:pt idx="0">
+                  <c:v>GPU tok/J</c:v>
+                </c:pt>
+              </c:strCache>
+            </c:strRef>
+          </c:tx>
+          <c:spPr>
+            <a:solidFill>
+              <a:srgbClr val="A3AEBD"/>
+            </a:solidFill>
+            <a:effectLst/>
+          </c:spPr>
+          <c:invertIfNegative val="0"/>
+          <c:dLbls>
+            <c:numFmt formatCode="0.00" sourceLinked="0"/>
+            <c:txPr>
+              <a:bodyPr/>
+              <a:lstStyle/>
+              <a:p>
+                <a:pPr>
+                  <a:defRPr b="0" i="0" strike="noStrike" sz="1200" u="none">
+                    <a:solidFill>
+                      <a:srgbClr val="1B2430"/>
+                    </a:solidFill>
+                    <a:latin typeface="+mn-lt"/>
+                  </a:defRPr>
+                </a:pPr>
+              </a:p>
+            </c:txPr>
+            <c:showLegendKey val="0"/>
+            <c:showVal val="1"/>
+            <c:showCatName val="0"/>
+            <c:showSerName val="0"/>
+            <c:showPercent val="0"/>
+            <c:showBubbleSize val="0"/>
+            <c:showLeaderLines val="0"/>
+          </c:dLbls>
+          <c:dPt>
+            <c:idx val="0"/>
+            <c:invertIfNegative val="0"/>
+            <c:bubble3D val="0"/>
+            <c:spPr>
+              <a:solidFill>
+                <a:srgbClr val="A3AEBD"/>
+              </a:solidFill>
+              <a:effectLst/>
+            </c:spPr>
+          </c:dPt>
+          <c:dPt>
+            <c:idx val="1"/>
+            <c:invertIfNegative val="0"/>
+            <c:bubble3D val="0"/>
+            <c:spPr>
+              <a:solidFill>
+                <a:srgbClr val="5B6C8F"/>
+              </a:solidFill>
+              <a:effectLst/>
+            </c:spPr>
+          </c:dPt>
+          <c:dPt>
+            <c:idx val="2"/>
+            <c:invertIfNegative val="0"/>
+            <c:bubble3D val="0"/>
+            <c:spPr>
+              <a:solidFill>
+                <a:srgbClr val="0E9F8E"/>
+              </a:solidFill>
+              <a:effectLst/>
+            </c:spPr>
+          </c:dPt>
+          <c:cat>
+            <c:multiLvlStrRef>
+              <c:f>Sheet1!$A$2:$A$4</c:f>
+              <c:multiLvlStrCache>
+                <c:ptCount val="3"/>
+                <c:lvl>
+                  <c:pt idx="0">
+                    <c:v>vLLM alone</c:v>
+                  </c:pt>
+                  <c:pt idx="1">
+                    <c:v>+ LMCache</c:v>
+                  </c:pt>
+                  <c:pt idx="2">
+                    <c:v>+ LifeboatCache</c:v>
+                  </c:pt>
+                </c:lvl>
+              </c:multiLvlStrCache>
+            </c:multiLvlStrRef>
+          </c:cat>
+          <c:val>
+            <c:numRef>
+              <c:f>Sheet1!$B$2:$B$4</c:f>
+              <c:numCache>
+                <c:formatCode>General</c:formatCode>
+                <c:ptCount val="3"/>
+                <c:pt idx="0">
+                  <c:v>1.9</c:v>
+                </c:pt>
+                <c:pt idx="1">
+                  <c:v>1.95</c:v>
+                </c:pt>
+                <c:pt idx="2">
+                  <c:v>2.55</c:v>
+                </c:pt>
+              </c:numCache>
+            </c:numRef>
+          </c:val>
+        </c:ser>
+        <c:dLbls>
+          <c:numFmt formatCode="0.00" sourceLinked="0"/>
+          <c:txPr>
+            <a:bodyPr/>
+            <a:lstStyle/>
+            <a:p>
+              <a:pPr>
+                <a:defRPr b="0" i="0" strike="noStrike" sz="1200" u="none">
+                  <a:solidFill>
+                    <a:srgbClr val="1B2430"/>
+                  </a:solidFill>
+                  <a:latin typeface="+mn-lt"/>
+                </a:defRPr>
+              </a:pPr>
+            </a:p>
+          </c:txPr>
+          <c:showLegendKey val="0"/>
+          <c:showVal val="1"/>
+          <c:showCatName val="0"/>
+          <c:showSerName val="0"/>
+          <c:showPercent val="0"/>
+          <c:showBubbleSize val="0"/>
+          <c:showLeaderLines val="0"/>
+        </c:dLbls>
+        <c:gapWidth val="50"/>
         <c:overlap val="0"/>
         <c:axId val="2094734554"/>
         <c:axId val="2094734552"/>
@@ -5840,6 +6447,94 @@
             <a:fld id="{F7021451-1387-4CA6-816F-3879F97B5CBC}" type="slidenum">
               <a:rPr lang="en-US"/>
               <a:t>16</a:t>
+            </a:fld>
+            <a:endParaRPr lang="en-US"/>
+          </a:p>
+        </p:txBody>
+      </p:sp>
+    </p:spTree>
+    <p:extLst>
+      <p:ext uri="{BB962C8B-B14F-4D97-AF65-F5344CB8AC3E}">
+        <p14:creationId xmlns:p14="http://schemas.microsoft.com/office/powerpoint/2010/main" val="1024086991"/>
+      </p:ext>
+    </p:extLst>
+  </p:cSld>
+  <p:clrMapOvr>
+    <a:masterClrMapping/>
+  </p:clrMapOvr>
+</p:notes>
+</file>
+
+<file path=ppt/notesSlides/notesSlide17.xml><?xml version="1.0" encoding="utf-8"?>
+<p:notes xmlns:a="http://schemas.openxmlformats.org/drawingml/2006/main" xmlns:r="http://schemas.openxmlformats.org/officeDocument/2006/relationships" xmlns:p="http://schemas.openxmlformats.org/presentationml/2006/main">
+  <p:cSld>
+    <p:spTree>
+      <p:nvGrpSpPr>
+        <p:cNvPr id="1" name=""/>
+        <p:cNvGrpSpPr/>
+        <p:nvPr/>
+      </p:nvGrpSpPr>
+      <p:grpSpPr>
+        <a:xfrm>
+          <a:off x="0" y="0"/>
+          <a:ext cx="0" cy="0"/>
+          <a:chOff x="0" y="0"/>
+          <a:chExt cx="0" cy="0"/>
+        </a:xfrm>
+      </p:grpSpPr>
+      <p:sp>
+        <p:nvSpPr>
+          <p:cNvPr id="2" name="Slide Image Placeholder 1"/>
+          <p:cNvSpPr>
+            <a:spLocks noGrp="1" noRot="1" noChangeAspect="1"/>
+          </p:cNvSpPr>
+          <p:nvPr>
+            <p:ph type="sldImg"/>
+          </p:nvPr>
+        </p:nvSpPr>
+        <p:spPr/>
+      </p:sp>
+      <p:sp>
+        <p:nvSpPr>
+          <p:cNvPr id="3" name="Notes Placeholder 2"/>
+          <p:cNvSpPr>
+            <a:spLocks noGrp="1"/>
+          </p:cNvSpPr>
+          <p:nvPr>
+            <p:ph type="body" idx="1"/>
+          </p:nvPr>
+        </p:nvSpPr>
+        <p:spPr/>
+        <p:txBody>
+          <a:bodyPr/>
+          <a:lstStyle/>
+          <a:p>
+            <a:r>
+              <a:rPr lang="en-US" dirty="0"/>
+              <a:t/>
+            </a:r>
+            <a:endParaRPr lang="en-US" dirty="0"/>
+          </a:p>
+        </p:txBody>
+      </p:sp>
+      <p:sp>
+        <p:nvSpPr>
+          <p:cNvPr id="4" name="Slide Number Placeholder 3"/>
+          <p:cNvSpPr>
+            <a:spLocks noGrp="1"/>
+          </p:cNvSpPr>
+          <p:nvPr>
+            <p:ph type="sldNum" sz="quarter" idx="10"/>
+          </p:nvPr>
+        </p:nvSpPr>
+        <p:spPr/>
+        <p:txBody>
+          <a:bodyPr/>
+          <a:lstStyle/>
+          <a:p>
+            <a:fld id="{F7021451-1387-4CA6-816F-3879F97B5CBC}" type="slidenum">
+              <a:rPr lang="en-US"/>
+              <a:t>17</a:t>
             </a:fld>
             <a:endParaRPr lang="en-US"/>
           </a:p>
@@ -8243,6 +8938,185 @@
                 <a:ea typeface="Cambria" pitchFamily="34" charset="-122"/>
                 <a:cs typeface="Cambria" pitchFamily="34" charset="-120"/>
               </a:rPr>
+              <a:t>gpt-oss-20b on one GPU: +28% throughput at 128 agents</a:t>
+            </a:r>
+            <a:endParaRPr lang="en-US" sz="3200" dirty="0"/>
+          </a:p>
+        </p:txBody>
+      </p:sp>
+      <p:graphicFrame>
+        <p:nvGraphicFramePr>
+          <p:cNvPr id="3" name="oss tps" descr=""/>
+          <p:cNvGraphicFramePr/>
+          <p:nvPr/>
+        </p:nvGraphicFramePr>
+        <p:xfrm>
+          <a:off x="548640" y="1371600"/>
+          <a:ext cx="5394960" cy="4206240"/>
+        </p:xfrm>
+        <a:graphic xmlns:a="http://schemas.openxmlformats.org/drawingml/2006/main">
+          <a:graphicData uri="http://schemas.openxmlformats.org/drawingml/2006/chart">
+            <c:chart xmlns:c="http://schemas.openxmlformats.org/drawingml/2006/chart" r:id="rId1"/>
+          </a:graphicData>
+        </a:graphic>
+      </p:graphicFrame>
+      <p:graphicFrame>
+        <p:nvGraphicFramePr>
+          <p:cNvPr id="4" name="oss tpj" descr=""/>
+          <p:cNvGraphicFramePr/>
+          <p:nvPr/>
+        </p:nvGraphicFramePr>
+        <p:xfrm>
+          <a:off x="6217920" y="1371600"/>
+          <a:ext cx="5394960" cy="4206240"/>
+        </p:xfrm>
+        <a:graphic xmlns:a="http://schemas.openxmlformats.org/drawingml/2006/main">
+          <a:graphicData uri="http://schemas.openxmlformats.org/drawingml/2006/chart">
+            <c:chart xmlns:c="http://schemas.openxmlformats.org/drawingml/2006/chart" r:id="rId2"/>
+          </a:graphicData>
+        </a:graphic>
+      </p:graphicFrame>
+      <p:sp>
+        <p:nvSpPr>
+          <p:cNvPr id="5" name="footnote"/>
+          <p:cNvSpPr txBox="1"/>
+          <p:nvPr/>
+        </p:nvSpPr>
+        <p:spPr>
+          <a:xfrm>
+            <a:off x="548640" y="5806440"/>
+            <a:ext cx="11064240" cy="502920"/>
+          </a:xfrm>
+          <a:prstGeom prst="rect">
+            <a:avLst/>
+          </a:prstGeom>
+          <a:noFill/>
+          <a:ln/>
+        </p:spPr>
+        <p:txBody>
+          <a:bodyPr wrap="square" lIns="0" tIns="0" rIns="0" bIns="0" rtlCol="0" anchor="t"/>
+          <a:lstStyle/>
+          <a:p>
+            <a:pPr indent="0" marL="0">
+              <a:buNone/>
+            </a:pPr>
+            <a:r>
+              <a:rPr lang="en-US" sz="1100" dirty="0">
+                <a:solidFill>
+                  <a:schemeClr val="accent2"/>
+                </a:solidFill>
+              </a:rPr>
+              <a:t>One RTX PRO 6000, gpt-oss-20b (MXFP4), 128,000-token context, 25 rounds per agent, up to 512 output tokens per round; 24 GB host DRAM for both caches. Mean TTFT 0.49 / 0.64 / 0.44 s; share of prompt tokens from cache 80% / 82% / 89%.</a:t>
+            </a:r>
+            <a:endParaRPr lang="en-US" sz="1100" dirty="0"/>
+          </a:p>
+        </p:txBody>
+      </p:sp>
+      <p:sp>
+        <p:nvSpPr>
+          <p:cNvPr id="25" name="Slide Number Placeholder 0"/>
+          <p:cNvSpPr>
+            <a:spLocks noGrp="1"/>
+          </p:cNvSpPr>
+          <p:nvPr>
+            <p:ph type="sldNum" sz="quarter" idx="4294967295"/>
+          </p:nvPr>
+        </p:nvSpPr>
+        <p:spPr>
+          <a:xfrm>
+            <a:off x="11247120" y="6400800"/>
+            <a:ext cx="457200" cy="274320"/>
+          </a:xfrm>
+          <a:prstGeom prst="rect">
+            <a:avLst/>
+          </a:prstGeom>
+          <a:extLst>
+            <a:ext uri="{C572A759-6A51-4108-AA02-DFA0A04FC94B}">
+              <ma14:wrappingTextBoxFlag xmlns:ma14="http://schemas.microsoft.com/office/mac/drawingml/2011/main" val="0"/>
+            </a:ext>
+          </a:extLst>
+        </p:spPr>
+        <p:txBody>
+          <a:bodyPr/>
+          <a:lstStyle>
+            <a:lvl1pPr>
+              <a:defRPr sz="1000">
+                <a:solidFill>
+                  <a:srgbClr val="5B6C8F"/>
+                </a:solidFill>
+              </a:defRPr>
+            </a:lvl1pPr>
+          </a:lstStyle>
+          <a:p>
+            <a:pPr algn="l"/>
+            <a:fld id="{F7021451-1387-4CA6-816F-3879F97B5CBC}" type="slidenum">
+              <a:rPr b="0" lang="en-US"/>
+              <a:t>13</a:t>
+            </a:fld>
+            <a:endParaRPr lang="en-US"/>
+          </a:p>
+        </p:txBody>
+      </p:sp>
+    </p:spTree>
+  </p:cSld>
+  <p:clrMapOvr>
+    <a:masterClrMapping/>
+  </p:clrMapOvr>
+</p:sld>
+</file>
+
+<file path=ppt/slides/slide14.xml><?xml version="1.0" encoding="utf-8"?>
+<p:sld xmlns:a="http://schemas.openxmlformats.org/drawingml/2006/main" xmlns:r="http://schemas.openxmlformats.org/officeDocument/2006/relationships" xmlns:p="http://schemas.openxmlformats.org/presentationml/2006/main">
+  <p:cSld name="Slide 14">
+    <p:spTree>
+      <p:nvGrpSpPr>
+        <p:cNvPr id="1" name=""/>
+        <p:cNvGrpSpPr/>
+        <p:nvPr/>
+      </p:nvGrpSpPr>
+      <p:grpSpPr>
+        <a:xfrm>
+          <a:off x="0" y="0"/>
+          <a:ext cx="0" cy="0"/>
+          <a:chOff x="0" y="0"/>
+          <a:chExt cx="0" cy="0"/>
+        </a:xfrm>
+      </p:grpSpPr>
+      <p:sp>
+        <p:nvSpPr>
+          <p:cNvPr id="2" name="Text 0"/>
+          <p:cNvSpPr/>
+          <p:nvPr>
+            <p:ph idx="100" type="title" hasCustomPrompt="1"/>
+          </p:nvPr>
+        </p:nvSpPr>
+        <p:spPr>
+          <a:xfrm>
+            <a:off x="548640" y="365760"/>
+            <a:ext cx="11064240" cy="822960"/>
+          </a:xfrm>
+          <a:prstGeom prst="rect">
+            <a:avLst/>
+          </a:prstGeom>
+          <a:noFill/>
+          <a:ln/>
+        </p:spPr>
+        <p:txBody>
+          <a:bodyPr wrap="square" lIns="0" tIns="0" rIns="0" bIns="0" rtlCol="0" anchor="ctr"/>
+          <a:lstStyle/>
+          <a:p>
+            <a:pPr algn="l" indent="0" marL="0">
+              <a:buNone/>
+            </a:pPr>
+            <a:r>
+              <a:rPr lang="en-US" sz="3200" b="1" dirty="0">
+                <a:solidFill>
+                  <a:schemeClr val="tx2"/>
+                </a:solidFill>
+                <a:latin typeface="Cambria" pitchFamily="34" charset="0"/>
+                <a:ea typeface="Cambria" pitchFamily="34" charset="-122"/>
+                <a:cs typeface="Cambria" pitchFamily="34" charset="-120"/>
+              </a:rPr>
               <a:t>32 agents: no overhead when the GPUs hold the sessions</a:t>
             </a:r>
             <a:endParaRPr lang="en-US" sz="3200" dirty="0"/>
@@ -8708,7 +9582,7 @@
             <a:pPr algn="l"/>
             <a:fld id="{F7021451-1387-4CA6-816F-3879F97B5CBC}" type="slidenum">
               <a:rPr b="0" lang="en-US"/>
-              <a:t>13</a:t>
+              <a:t>14</a:t>
             </a:fld>
             <a:endParaRPr lang="en-US"/>
           </a:p>
@@ -8722,9 +9596,9 @@
 </p:sld>
 </file>
 
-<file path=ppt/slides/slide14.xml><?xml version="1.0" encoding="utf-8"?>
+<file path=ppt/slides/slide15.xml><?xml version="1.0" encoding="utf-8"?>
 <p:sld xmlns:a="http://schemas.openxmlformats.org/drawingml/2006/main" xmlns:r="http://schemas.openxmlformats.org/officeDocument/2006/relationships" xmlns:p="http://schemas.openxmlformats.org/presentationml/2006/main">
-  <p:cSld name="Slide 14">
+  <p:cSld name="Slide 15">
     <p:spTree>
       <p:nvGrpSpPr>
         <p:cNvPr id="1" name=""/>
@@ -8782,7 +9656,7 @@
       </p:sp>
       <p:graphicFrame>
         <p:nvGraphicFramePr>
-          <p:cNvPr id="15" name="scale table"/>
+          <p:cNvPr id="16" name="scale table"/>
           <p:cNvGraphicFramePr>
             <a:graphicFrameLocks noGrp="1"/>
           </p:cNvGraphicFramePr>
@@ -9926,7 +10800,7 @@
             <a:pPr algn="l"/>
             <a:fld id="{F7021451-1387-4CA6-816F-3879F97B5CBC}" type="slidenum">
               <a:rPr b="0" lang="en-US"/>
-              <a:t>14</a:t>
+              <a:t>15</a:t>
             </a:fld>
             <a:endParaRPr lang="en-US"/>
           </a:p>
@@ -9940,9 +10814,9 @@
 </p:sld>
 </file>
 
-<file path=ppt/slides/slide15.xml><?xml version="1.0" encoding="utf-8"?>
+<file path=ppt/slides/slide16.xml><?xml version="1.0" encoding="utf-8"?>
 <p:sld xmlns:a="http://schemas.openxmlformats.org/drawingml/2006/main" xmlns:r="http://schemas.openxmlformats.org/officeDocument/2006/relationships" xmlns:p="http://schemas.openxmlformats.org/presentationml/2006/main">
-  <p:cSld name="Slide 15">
+  <p:cSld name="Slide 16">
     <p:spTree>
       <p:nvGrpSpPr>
         <p:cNvPr id="1" name=""/>
@@ -10000,7 +10874,7 @@
       </p:sp>
       <p:graphicFrame>
         <p:nvGraphicFramePr>
-          <p:cNvPr id="16" name="repeat table"/>
+          <p:cNvPr id="17" name="repeat table"/>
           <p:cNvGraphicFramePr>
             <a:graphicFrameLocks noGrp="1"/>
           </p:cNvGraphicFramePr>
@@ -10704,7 +11578,7 @@
             <a:pPr algn="l"/>
             <a:fld id="{F7021451-1387-4CA6-816F-3879F97B5CBC}" type="slidenum">
               <a:rPr b="0" lang="en-US"/>
-              <a:t>15</a:t>
+              <a:t>16</a:t>
             </a:fld>
             <a:endParaRPr lang="en-US"/>
           </a:p>
@@ -10718,9 +11592,9 @@
 </p:sld>
 </file>
 
-<file path=ppt/slides/slide16.xml><?xml version="1.0" encoding="utf-8"?>
+<file path=ppt/slides/slide17.xml><?xml version="1.0" encoding="utf-8"?>
 <p:sld xmlns:a="http://schemas.openxmlformats.org/drawingml/2006/main" xmlns:r="http://schemas.openxmlformats.org/officeDocument/2006/relationships" xmlns:p="http://schemas.openxmlformats.org/presentationml/2006/main">
-  <p:cSld name="Slide 16">
+  <p:cSld name="Slide 17">
     <p:spTree>
       <p:nvGrpSpPr>
         <p:cNvPr id="1" name=""/>

</xml_diff>

<commit_message>
gpt-oss-20b at 256 agents: vLLM alone vs LMCache vs LifeboatCache 0.1.24
Co-Authored-By: Claude Opus 5.5 <noreply@anthropic.com>
</commit_message>
<xml_diff>
--- a/reports/agentic-4x-rtxpro6000-qwen3-235b-a22b/LifeboatCache_vLLM_Agentic_4xRTXPRO6000.pptx
+++ b/reports/agentic-4x-rtxpro6000-qwen3-235b-a22b/LifeboatCache_vLLM_Agentic_4xRTXPRO6000.pptx
@@ -1662,7 +1662,7 @@
                 </a:solidFill>
                 <a:latin typeface="+mn-lt"/>
               </a:rPr>
-              <a:t>Output tokens/s, higher is better</a:t>
+              <a:t>Mean time to first token (s), lower is better</a:t>
             </a:r>
           </a:p>
         </c:rich>
@@ -1686,7 +1686,7 @@
               <c:strCache>
                 <c:ptCount val="1"/>
                 <c:pt idx="0">
-                  <c:v>Output tok/s</c:v>
+                  <c:v>vLLM alone</c:v>
                 </c:pt>
               </c:strCache>
             </c:strRef>
@@ -1699,7 +1699,7 @@
           </c:spPr>
           <c:invertIfNegative val="0"/>
           <c:dLbls>
-            <c:numFmt formatCode="#,##0" sourceLinked="0"/>
+            <c:numFmt formatCode="0.0" sourceLinked="0"/>
             <c:txPr>
               <a:bodyPr/>
               <a:lstStyle/>
@@ -1722,53 +1722,17 @@
             <c:showBubbleSize val="0"/>
             <c:showLeaderLines val="0"/>
           </c:dLbls>
-          <c:dPt>
-            <c:idx val="0"/>
-            <c:invertIfNegative val="0"/>
-            <c:bubble3D val="0"/>
-            <c:spPr>
-              <a:solidFill>
-                <a:srgbClr val="A3AEBD"/>
-              </a:solidFill>
-              <a:effectLst/>
-            </c:spPr>
-          </c:dPt>
-          <c:dPt>
-            <c:idx val="1"/>
-            <c:invertIfNegative val="0"/>
-            <c:bubble3D val="0"/>
-            <c:spPr>
-              <a:solidFill>
-                <a:srgbClr val="5B6C8F"/>
-              </a:solidFill>
-              <a:effectLst/>
-            </c:spPr>
-          </c:dPt>
-          <c:dPt>
-            <c:idx val="2"/>
-            <c:invertIfNegative val="0"/>
-            <c:bubble3D val="0"/>
-            <c:spPr>
-              <a:solidFill>
-                <a:srgbClr val="0E9F8E"/>
-              </a:solidFill>
-              <a:effectLst/>
-            </c:spPr>
-          </c:dPt>
           <c:cat>
             <c:multiLvlStrRef>
-              <c:f>Sheet1!$A$2:$A$4</c:f>
+              <c:f>Sheet1!$A$2:$A$3</c:f>
               <c:multiLvlStrCache>
-                <c:ptCount val="3"/>
+                <c:ptCount val="2"/>
                 <c:lvl>
                   <c:pt idx="0">
-                    <c:v>vLLM alone</c:v>
+                    <c:v>128 agents</c:v>
                   </c:pt>
                   <c:pt idx="1">
-                    <c:v>+ LMCache</c:v>
-                  </c:pt>
-                  <c:pt idx="2">
-                    <c:v>+ LifeboatCache</c:v>
+                    <c:v>256 agents</c:v>
                   </c:pt>
                 </c:lvl>
               </c:multiLvlStrCache>
@@ -1776,25 +1740,176 @@
           </c:cat>
           <c:val>
             <c:numRef>
-              <c:f>Sheet1!$B$2:$B$4</c:f>
+              <c:f>Sheet1!$B$2:$B$3</c:f>
               <c:numCache>
                 <c:formatCode>General</c:formatCode>
-                <c:ptCount val="3"/>
+                <c:ptCount val="2"/>
                 <c:pt idx="0">
-                  <c:v>1117</c:v>
+                  <c:v>0.5</c:v>
                 </c:pt>
                 <c:pt idx="1">
-                  <c:v>1144</c:v>
+                  <c:v>70.7</c:v>
                 </c:pt>
-                <c:pt idx="2">
-                  <c:v>1425</c:v>
+              </c:numCache>
+            </c:numRef>
+          </c:val>
+        </c:ser>
+        <c:ser>
+          <c:idx val="1"/>
+          <c:order val="1"/>
+          <c:tx>
+            <c:strRef>
+              <c:f>Sheet1!$C$1</c:f>
+              <c:strCache>
+                <c:ptCount val="1"/>
+                <c:pt idx="0">
+                  <c:v>+ LMCache</c:v>
+                </c:pt>
+              </c:strCache>
+            </c:strRef>
+          </c:tx>
+          <c:spPr>
+            <a:solidFill>
+              <a:srgbClr val="5B6C8F"/>
+            </a:solidFill>
+            <a:effectLst/>
+          </c:spPr>
+          <c:invertIfNegative val="0"/>
+          <c:dLbls>
+            <c:numFmt formatCode="0.0" sourceLinked="0"/>
+            <c:txPr>
+              <a:bodyPr/>
+              <a:lstStyle/>
+              <a:p>
+                <a:pPr>
+                  <a:defRPr b="0" i="0" strike="noStrike" sz="1200" u="none">
+                    <a:solidFill>
+                      <a:srgbClr val="1B2430"/>
+                    </a:solidFill>
+                    <a:latin typeface="+mn-lt"/>
+                  </a:defRPr>
+                </a:pPr>
+              </a:p>
+            </c:txPr>
+            <c:showLegendKey val="0"/>
+            <c:showVal val="1"/>
+            <c:showCatName val="0"/>
+            <c:showSerName val="0"/>
+            <c:showPercent val="0"/>
+            <c:showBubbleSize val="0"/>
+            <c:showLeaderLines val="0"/>
+          </c:dLbls>
+          <c:cat>
+            <c:multiLvlStrRef>
+              <c:f>Sheet1!$A$2:$A$3</c:f>
+              <c:multiLvlStrCache>
+                <c:ptCount val="2"/>
+                <c:lvl>
+                  <c:pt idx="0">
+                    <c:v>128 agents</c:v>
+                  </c:pt>
+                  <c:pt idx="1">
+                    <c:v>256 agents</c:v>
+                  </c:pt>
+                </c:lvl>
+              </c:multiLvlStrCache>
+            </c:multiLvlStrRef>
+          </c:cat>
+          <c:val>
+            <c:numRef>
+              <c:f>Sheet1!$C$2:$C$3</c:f>
+              <c:numCache>
+                <c:formatCode>General</c:formatCode>
+                <c:ptCount val="2"/>
+                <c:pt idx="0">
+                  <c:v>0.6</c:v>
+                </c:pt>
+                <c:pt idx="1">
+                  <c:v>68.7</c:v>
+                </c:pt>
+              </c:numCache>
+            </c:numRef>
+          </c:val>
+        </c:ser>
+        <c:ser>
+          <c:idx val="2"/>
+          <c:order val="2"/>
+          <c:tx>
+            <c:strRef>
+              <c:f>Sheet1!$D$1</c:f>
+              <c:strCache>
+                <c:ptCount val="1"/>
+                <c:pt idx="0">
+                  <c:v>+ LifeboatCache</c:v>
+                </c:pt>
+              </c:strCache>
+            </c:strRef>
+          </c:tx>
+          <c:spPr>
+            <a:solidFill>
+              <a:srgbClr val="0E9F8E"/>
+            </a:solidFill>
+            <a:effectLst/>
+          </c:spPr>
+          <c:invertIfNegative val="0"/>
+          <c:dLbls>
+            <c:numFmt formatCode="0.0" sourceLinked="0"/>
+            <c:txPr>
+              <a:bodyPr/>
+              <a:lstStyle/>
+              <a:p>
+                <a:pPr>
+                  <a:defRPr b="0" i="0" strike="noStrike" sz="1200" u="none">
+                    <a:solidFill>
+                      <a:srgbClr val="1B2430"/>
+                    </a:solidFill>
+                    <a:latin typeface="+mn-lt"/>
+                  </a:defRPr>
+                </a:pPr>
+              </a:p>
+            </c:txPr>
+            <c:showLegendKey val="0"/>
+            <c:showVal val="1"/>
+            <c:showCatName val="0"/>
+            <c:showSerName val="0"/>
+            <c:showPercent val="0"/>
+            <c:showBubbleSize val="0"/>
+            <c:showLeaderLines val="0"/>
+          </c:dLbls>
+          <c:cat>
+            <c:multiLvlStrRef>
+              <c:f>Sheet1!$A$2:$A$3</c:f>
+              <c:multiLvlStrCache>
+                <c:ptCount val="2"/>
+                <c:lvl>
+                  <c:pt idx="0">
+                    <c:v>128 agents</c:v>
+                  </c:pt>
+                  <c:pt idx="1">
+                    <c:v>256 agents</c:v>
+                  </c:pt>
+                </c:lvl>
+              </c:multiLvlStrCache>
+            </c:multiLvlStrRef>
+          </c:cat>
+          <c:val>
+            <c:numRef>
+              <c:f>Sheet1!$D$2:$D$3</c:f>
+              <c:numCache>
+                <c:formatCode>General</c:formatCode>
+                <c:ptCount val="2"/>
+                <c:pt idx="0">
+                  <c:v>0.4</c:v>
+                </c:pt>
+                <c:pt idx="1">
+                  <c:v>54.4</c:v>
                 </c:pt>
               </c:numCache>
             </c:numRef>
           </c:val>
         </c:ser>
         <c:dLbls>
-          <c:numFmt formatCode="#,##0" sourceLinked="0"/>
+          <c:numFmt formatCode="0.0" sourceLinked="0"/>
           <c:txPr>
             <a:bodyPr/>
             <a:lstStyle/>
@@ -1923,6 +2038,23 @@
         <a:effectLst/>
       </c:spPr>
     </c:plotArea>
+    <c:legend>
+      <c:legendPos val="b"/>
+      <c:overlay val="0"/>
+      <c:txPr>
+        <a:bodyPr/>
+        <a:lstStyle/>
+        <a:p>
+          <a:pPr>
+            <a:defRPr sz="1100">
+              <a:latin typeface="+mn-lt"/>
+              <a:cs typeface="+mn-lt"/>
+            </a:defRPr>
+          </a:pPr>
+          <a:endParaRPr lang="en-US"/>
+        </a:p>
+      </c:txPr>
+    </c:legend>
     <c:plotVisOnly val="1"/>
     <c:dispBlanksAs val="span"/>
   </c:chart>
@@ -1989,7 +2121,7 @@
               <c:strCache>
                 <c:ptCount val="1"/>
                 <c:pt idx="0">
-                  <c:v>GPU tok/J</c:v>
+                  <c:v>vLLM alone</c:v>
                 </c:pt>
               </c:strCache>
             </c:strRef>
@@ -2025,53 +2157,17 @@
             <c:showBubbleSize val="0"/>
             <c:showLeaderLines val="0"/>
           </c:dLbls>
-          <c:dPt>
-            <c:idx val="0"/>
-            <c:invertIfNegative val="0"/>
-            <c:bubble3D val="0"/>
-            <c:spPr>
-              <a:solidFill>
-                <a:srgbClr val="A3AEBD"/>
-              </a:solidFill>
-              <a:effectLst/>
-            </c:spPr>
-          </c:dPt>
-          <c:dPt>
-            <c:idx val="1"/>
-            <c:invertIfNegative val="0"/>
-            <c:bubble3D val="0"/>
-            <c:spPr>
-              <a:solidFill>
-                <a:srgbClr val="5B6C8F"/>
-              </a:solidFill>
-              <a:effectLst/>
-            </c:spPr>
-          </c:dPt>
-          <c:dPt>
-            <c:idx val="2"/>
-            <c:invertIfNegative val="0"/>
-            <c:bubble3D val="0"/>
-            <c:spPr>
-              <a:solidFill>
-                <a:srgbClr val="0E9F8E"/>
-              </a:solidFill>
-              <a:effectLst/>
-            </c:spPr>
-          </c:dPt>
           <c:cat>
             <c:multiLvlStrRef>
-              <c:f>Sheet1!$A$2:$A$4</c:f>
+              <c:f>Sheet1!$A$2:$A$3</c:f>
               <c:multiLvlStrCache>
-                <c:ptCount val="3"/>
+                <c:ptCount val="2"/>
                 <c:lvl>
                   <c:pt idx="0">
-                    <c:v>vLLM alone</c:v>
+                    <c:v>128 agents</c:v>
                   </c:pt>
                   <c:pt idx="1">
-                    <c:v>+ LMCache</c:v>
-                  </c:pt>
-                  <c:pt idx="2">
-                    <c:v>+ LifeboatCache</c:v>
+                    <c:v>256 agents</c:v>
                   </c:pt>
                 </c:lvl>
               </c:multiLvlStrCache>
@@ -2079,18 +2175,169 @@
           </c:cat>
           <c:val>
             <c:numRef>
-              <c:f>Sheet1!$B$2:$B$4</c:f>
+              <c:f>Sheet1!$B$2:$B$3</c:f>
               <c:numCache>
                 <c:formatCode>General</c:formatCode>
-                <c:ptCount val="3"/>
+                <c:ptCount val="2"/>
                 <c:pt idx="0">
                   <c:v>1.9</c:v>
                 </c:pt>
                 <c:pt idx="1">
+                  <c:v>0.57</c:v>
+                </c:pt>
+              </c:numCache>
+            </c:numRef>
+          </c:val>
+        </c:ser>
+        <c:ser>
+          <c:idx val="1"/>
+          <c:order val="1"/>
+          <c:tx>
+            <c:strRef>
+              <c:f>Sheet1!$C$1</c:f>
+              <c:strCache>
+                <c:ptCount val="1"/>
+                <c:pt idx="0">
+                  <c:v>+ LMCache</c:v>
+                </c:pt>
+              </c:strCache>
+            </c:strRef>
+          </c:tx>
+          <c:spPr>
+            <a:solidFill>
+              <a:srgbClr val="5B6C8F"/>
+            </a:solidFill>
+            <a:effectLst/>
+          </c:spPr>
+          <c:invertIfNegative val="0"/>
+          <c:dLbls>
+            <c:numFmt formatCode="0.00" sourceLinked="0"/>
+            <c:txPr>
+              <a:bodyPr/>
+              <a:lstStyle/>
+              <a:p>
+                <a:pPr>
+                  <a:defRPr b="0" i="0" strike="noStrike" sz="1200" u="none">
+                    <a:solidFill>
+                      <a:srgbClr val="1B2430"/>
+                    </a:solidFill>
+                    <a:latin typeface="+mn-lt"/>
+                  </a:defRPr>
+                </a:pPr>
+              </a:p>
+            </c:txPr>
+            <c:showLegendKey val="0"/>
+            <c:showVal val="1"/>
+            <c:showCatName val="0"/>
+            <c:showSerName val="0"/>
+            <c:showPercent val="0"/>
+            <c:showBubbleSize val="0"/>
+            <c:showLeaderLines val="0"/>
+          </c:dLbls>
+          <c:cat>
+            <c:multiLvlStrRef>
+              <c:f>Sheet1!$A$2:$A$3</c:f>
+              <c:multiLvlStrCache>
+                <c:ptCount val="2"/>
+                <c:lvl>
+                  <c:pt idx="0">
+                    <c:v>128 agents</c:v>
+                  </c:pt>
+                  <c:pt idx="1">
+                    <c:v>256 agents</c:v>
+                  </c:pt>
+                </c:lvl>
+              </c:multiLvlStrCache>
+            </c:multiLvlStrRef>
+          </c:cat>
+          <c:val>
+            <c:numRef>
+              <c:f>Sheet1!$C$2:$C$3</c:f>
+              <c:numCache>
+                <c:formatCode>General</c:formatCode>
+                <c:ptCount val="2"/>
+                <c:pt idx="0">
                   <c:v>1.95</c:v>
                 </c:pt>
-                <c:pt idx="2">
+                <c:pt idx="1">
+                  <c:v>0.58</c:v>
+                </c:pt>
+              </c:numCache>
+            </c:numRef>
+          </c:val>
+        </c:ser>
+        <c:ser>
+          <c:idx val="2"/>
+          <c:order val="2"/>
+          <c:tx>
+            <c:strRef>
+              <c:f>Sheet1!$D$1</c:f>
+              <c:strCache>
+                <c:ptCount val="1"/>
+                <c:pt idx="0">
+                  <c:v>+ LifeboatCache</c:v>
+                </c:pt>
+              </c:strCache>
+            </c:strRef>
+          </c:tx>
+          <c:spPr>
+            <a:solidFill>
+              <a:srgbClr val="0E9F8E"/>
+            </a:solidFill>
+            <a:effectLst/>
+          </c:spPr>
+          <c:invertIfNegative val="0"/>
+          <c:dLbls>
+            <c:numFmt formatCode="0.00" sourceLinked="0"/>
+            <c:txPr>
+              <a:bodyPr/>
+              <a:lstStyle/>
+              <a:p>
+                <a:pPr>
+                  <a:defRPr b="0" i="0" strike="noStrike" sz="1200" u="none">
+                    <a:solidFill>
+                      <a:srgbClr val="1B2430"/>
+                    </a:solidFill>
+                    <a:latin typeface="+mn-lt"/>
+                  </a:defRPr>
+                </a:pPr>
+              </a:p>
+            </c:txPr>
+            <c:showLegendKey val="0"/>
+            <c:showVal val="1"/>
+            <c:showCatName val="0"/>
+            <c:showSerName val="0"/>
+            <c:showPercent val="0"/>
+            <c:showBubbleSize val="0"/>
+            <c:showLeaderLines val="0"/>
+          </c:dLbls>
+          <c:cat>
+            <c:multiLvlStrRef>
+              <c:f>Sheet1!$A$2:$A$3</c:f>
+              <c:multiLvlStrCache>
+                <c:ptCount val="2"/>
+                <c:lvl>
+                  <c:pt idx="0">
+                    <c:v>128 agents</c:v>
+                  </c:pt>
+                  <c:pt idx="1">
+                    <c:v>256 agents</c:v>
+                  </c:pt>
+                </c:lvl>
+              </c:multiLvlStrCache>
+            </c:multiLvlStrRef>
+          </c:cat>
+          <c:val>
+            <c:numRef>
+              <c:f>Sheet1!$D$2:$D$3</c:f>
+              <c:numCache>
+                <c:formatCode>General</c:formatCode>
+                <c:ptCount val="2"/>
+                <c:pt idx="0">
                   <c:v>2.55</c:v>
+                </c:pt>
+                <c:pt idx="1">
+                  <c:v>0.74</c:v>
                 </c:pt>
               </c:numCache>
             </c:numRef>
@@ -2226,6 +2473,23 @@
         <a:effectLst/>
       </c:spPr>
     </c:plotArea>
+    <c:legend>
+      <c:legendPos val="b"/>
+      <c:overlay val="0"/>
+      <c:txPr>
+        <a:bodyPr/>
+        <a:lstStyle/>
+        <a:p>
+          <a:pPr>
+            <a:defRPr sz="1100">
+              <a:latin typeface="+mn-lt"/>
+              <a:cs typeface="+mn-lt"/>
+            </a:defRPr>
+          </a:pPr>
+          <a:endParaRPr lang="en-US"/>
+        </a:p>
+      </c:txPr>
+    </c:legend>
     <c:plotVisOnly val="1"/>
     <c:dispBlanksAs val="span"/>
   </c:chart>
@@ -8938,7 +9202,7 @@
                 <a:ea typeface="Cambria" pitchFamily="34" charset="-122"/>
                 <a:cs typeface="Cambria" pitchFamily="34" charset="-120"/>
               </a:rPr>
-              <a:t>gpt-oss-20b on one GPU: +28% throughput at 128 agents</a:t>
+              <a:t>gpt-oss-20b on one GPU: 23% lower TTFT at 256 agents</a:t>
             </a:r>
             <a:endParaRPr lang="en-US" sz="3200" dirty="0"/>
           </a:p>
@@ -8946,13 +9210,13 @@
       </p:sp>
       <p:graphicFrame>
         <p:nvGraphicFramePr>
-          <p:cNvPr id="3" name="oss tps" descr=""/>
+          <p:cNvPr id="3" name="oss ttft" descr=""/>
           <p:cNvGraphicFramePr/>
           <p:nvPr/>
         </p:nvGraphicFramePr>
         <p:xfrm>
           <a:off x="548640" y="1371600"/>
-          <a:ext cx="5394960" cy="4206240"/>
+          <a:ext cx="5394960" cy="4114800"/>
         </p:xfrm>
         <a:graphic xmlns:a="http://schemas.openxmlformats.org/drawingml/2006/main">
           <a:graphicData uri="http://schemas.openxmlformats.org/drawingml/2006/chart">
@@ -8968,7 +9232,7 @@
         </p:nvGraphicFramePr>
         <p:xfrm>
           <a:off x="6217920" y="1371600"/>
-          <a:ext cx="5394960" cy="4206240"/>
+          <a:ext cx="5394960" cy="4114800"/>
         </p:xfrm>
         <a:graphic xmlns:a="http://schemas.openxmlformats.org/drawingml/2006/main">
           <a:graphicData uri="http://schemas.openxmlformats.org/drawingml/2006/chart">
@@ -8984,7 +9248,7 @@
         </p:nvSpPr>
         <p:spPr>
           <a:xfrm>
-            <a:off x="548640" y="5806440"/>
+            <a:off x="548640" y="5669280"/>
             <a:ext cx="11064240" cy="502920"/>
           </a:xfrm>
           <a:prstGeom prst="rect">
@@ -9006,7 +9270,7 @@
                   <a:schemeClr val="accent2"/>
                 </a:solidFill>
               </a:rPr>
-              <a:t>One RTX PRO 6000, gpt-oss-20b (MXFP4), 128,000-token context, 25 rounds per agent, up to 512 output tokens per round; 24 GB host DRAM for both caches. Mean TTFT 0.49 / 0.64 / 0.44 s; share of prompt tokens from cache 80% / 82% / 89%.</a:t>
+              <a:t>One RTX PRO 6000, gpt-oss-20b (MXFP4), 128,000-token context, 25 rounds per agent, up to 512 output tokens per round; 24 GB host DRAM for both caches. Throughput and cached share (vLLM alone / + LMCache / + LifeboatCache): 128 agents 1117 / 1144 / 1425 tok/s, cached 80% / 82% / 89%; 256 agents 342 / 349 / 349 tok/s, cached 7% / 9% / 40%.</a:t>
             </a:r>
             <a:endParaRPr lang="en-US" sz="1100" dirty="0"/>
           </a:p>

</xml_diff>